<commit_message>
Presentatie 12 oktober: dia over de SEBIA-opleiding, nieuwe kaart van de centra
- Zes sessies volgens het trainingsdeck van F. Dobbels (23/9), met data en groepen uit de opleidingsplanning
- Kaart met de logo's van de centra overgenomen uit de webversie

Co-Authored-By: Claude Opus 5.5 <noreply@anthropic.com>
</commit_message>
<xml_diff>
--- a/PARADISE_presentatie/webdecks/PARADISE_voetklinieken_12okt.pptx
+++ b/PARADISE_presentatie/webdecks/PARADISE_voetklinieken_12okt.pptx
@@ -28,6 +28,7 @@
     <p:sldId id="276" r:id="rId28"/>
     <p:sldId id="277" r:id="rId29"/>
     <p:sldId id="278" r:id="rId30"/>
+    <p:sldId id="279" r:id="rId31"/>
   </p:sldIdLst>
   <p:sldSz cx="12192000" cy="6858000" type="screen4x3"/>
   <p:notesSz cx="6858000" cy="9144000"/>
@@ -20679,7 +20680,7 @@
           <a:lstStyle/>
           <a:p>
             <a:r>
-              <a:t>Per centrum de voorgestelde data, allemaal gekozen op dagen dat uw podoloog er volgens uw eigen opgave is; voor Antwerpen valt de donderdag in een even week. SEBIA volgt de agenda van de lesgever, Fabienne Dobbels. SEBIA 1 en 2 gebeurt overdag, in drie groepen, want er is geen moment waarop Kortrijk, Brugge en Gent samen kunnen. Kortrijk en de eerste podoloog van Brugge op woensdag 6 januari in de namiddag, met woensdag 16 december als optie B. Groep Oost, met Aalst, Leuven en Antwerpen, en de tweede podoloog van Brugge op dinsdag 12 januari in de namiddag, na de datacollectie online in de voormiddag. Gent op vrijdag 15 januari in de namiddag, in het eigen centrum, met vrijdag 11 december als optie B; de droogloop van Gent schuift daarvoor naar donderdag 21 januari. Voor SEBIA 3 en 4 stellen we dezelfde drie groepen voor, op 9, 10 en 12 maart, maar mevrouw Dobbels gaf na januari nog geen data; die vragen we eerst bij haar op. Waar een datum niet voor iedereen lukt, staat op uw toetsingsblad een optie B. Graag uw antwoord tegen vrijdag 16 oktober; daarna ligt de kalender vast.</a:t>
+              <a:t>Hoe we de SEBIA-opleiding zien. SEBIA heeft twee doelen: goede voetzorg, via educatie en vaardigheidstraining, en therapietrouw aan het schoeisel, via monitoring, motivatie en het aanpakken van drempels. Het SEBIA-gesprek komt op elke visite van de PARADISE-arm terug: op de eerste visites ligt de focus op educatie, daarna op de draagtijd, en op maand 6 en 12 op beide. Fabienne Dobbels geeft de opleiding aan de podologen, in zes sessies. Sessie 1 gaat over het geven van educatie: de patiënt als volwassen lerende, need to know tegenover nice to know, teach-back en show-me, en het voordoen van de voetzorg. Sessie 2 over het evalueren van kennis en vaardigheden met de NAFF, het uitlezen van de sensor met een uitdraai, en feedback over het dragen van de zolen. Die twee samen duren vier uur, overdag in januari, in drie groepen: Kortrijk met de eerste podoloog van Brugge op woensdag 6 januari, groep Oost met de tweede podoloog van Brugge op dinsdag 12 januari, en Gent op vrijdag 15 januari, telkens in de namiddag. Sessie 3 en 4 gaan over motiverende gespreksvoering: de motivatie van de patiënt inschatten en een interventie kiezen die daarbij past; samen weer vier uur, in dezelfde groepen. We stellen 9, 10 en 12 maart voor, maar mevrouw Dobbels gaf na januari nog geen data; die vragen we eerst bij haar op. Sessie 5 is een individuele oefensessie van anderhalf uur in uw eigen centrum, met rollenspel op de scripts, tussen 15 en 26 maart. Sessie 6 is een online intervisie van een uur, individueel, zes tot negen maanden na de start van de inclusie, dus van september tot november 2027: casussen bespreken en bijsturen waar het moeilijk loopt. De praktijksessies worden niet opgenomen, dus daar is aanwezigheid nodig.</a:t>
             </a:r>
           </a:p>
         </p:txBody>
@@ -20749,7 +20750,7 @@
           <a:lstStyle/>
           <a:p>
             <a:r>
-              <a:t>We vragen elk centrum drie inclusies per maand. Patiënten komen niet netjes op regelmatige tijdstippen binnen; daarom rekenden we met willekeurige instroom. De curve toont de kans dat een centrum zijn 24 binnen twaalf maanden haalt, bij elk gemiddeld tempo. Aan twee per maand ligt het doel precies op het gemiddelde: het is een muntworp, 53 procent. Aan drie per maand is het 99 procent. De studie is pas rond als het traagste centrum klaar is: dat alle zes het binnen het jaar halen, is aan drie per maand 92 procent, aan twee per maand amper 2 procent. De helft van de centra is aan drie per maand na 7,9 maanden of sneller klaar. De inclusie start eind februari 2027, meteen na de Go/No-Go van 23 februari. Twaalf maanden inclusie betekent 144 gerandomiseerd eind februari 2028, zoals het protocol voorziet. Met achttien maanden opvolging valt de laatste visite dan eind augustus 2029, één maand vóór de geplande laatste visite in september. Een eerlijke kanttekening: deze cijfers gaan ervan uit dat elk centrum echt drie per maand haalt. Verschillen de centra onderling, dan is het minder zeker. Daarover gaat de dia na de volgende.</a:t>
+              <a:t>Per centrum de voorgestelde data, allemaal gekozen op dagen dat uw podoloog er volgens uw eigen opgave is; voor Antwerpen valt de donderdag in een even week. SEBIA volgt de agenda van de lesgever, Fabienne Dobbels. SEBIA 1 en 2 gebeurt overdag, in drie groepen, want er is geen moment waarop Kortrijk, Brugge en Gent samen kunnen. Kortrijk en de eerste podoloog van Brugge op woensdag 6 januari in de namiddag, met woensdag 16 december als optie B. Groep Oost, met Aalst, Leuven en Antwerpen, en de tweede podoloog van Brugge op dinsdag 12 januari in de namiddag, na de datacollectie online in de voormiddag. Gent op vrijdag 15 januari in de namiddag, in het eigen centrum, met vrijdag 11 december als optie B; de droogloop van Gent schuift daarvoor naar donderdag 21 januari. Voor SEBIA 3 en 4 stellen we dezelfde drie groepen voor, op 9, 10 en 12 maart, maar mevrouw Dobbels gaf na januari nog geen data; die vragen we eerst bij haar op. Waar een datum niet voor iedereen lukt, staat op uw toetsingsblad een optie B. Graag uw antwoord tegen vrijdag 16 oktober; daarna ligt de kalender vast.</a:t>
             </a:r>
           </a:p>
         </p:txBody>
@@ -20819,7 +20820,7 @@
           <a:lstStyle/>
           <a:p>
             <a:r>
-              <a:t>Wat als een centrum twee per maand haalt in plaats van drie? De grafiek toont, maand na maand, hoeveel kans er is dat de inclusie klaar is: de volle lijnen voor één centrum, de streepjeslijnen voor alle zes samen. Blauw is drie per maand, oranje twee. Aan twee per maand duurt het gemiddeld twaalf maanden per centrum, met een spreiding van tweeënhalve maand: acht op tien centra zijn klaar tussen negen en vijftien maanden. Na een jaar is gemiddeld maar de helft van de centra rond, drie van de zes. De studie is pas rond als het traagste centrum klaar is. De geplande laatste visite is september 2029; achttien maanden terug is dat eind maart 2028, de uiterste datum voor de laatste inclusie. We starten eind februari 2027, meteen na de Go/No-Go; dan zijn dat dertien maanden: de verticale lijn. Aan twee per maand halen alle zes die grens maar in 12 procent van de gevallen; aan drie per maand in 98 procent. In de helft van de gevallen is het laatste centrum pas na vijftien maanden klaar, en valt de laatste visite eind november 2029; in één op tien pas in februari 2030. En in acht procent is na achttien maanden nog altijd een centrum niet rond. Dit is gerekend met zes centra die allemaal even snel zijn. Verschillen ze onderling, dan wordt het nog later; dat toont de volgende dia.</a:t>
+              <a:t>We vragen elk centrum drie inclusies per maand. Patiënten komen niet netjes op regelmatige tijdstippen binnen; daarom rekenden we met willekeurige instroom. De curve toont de kans dat een centrum zijn 24 binnen twaalf maanden haalt, bij elk gemiddeld tempo. Aan twee per maand ligt het doel precies op het gemiddelde: het is een muntworp, 53 procent. Aan drie per maand is het 99 procent. De studie is pas rond als het traagste centrum klaar is: dat alle zes het binnen het jaar halen, is aan drie per maand 92 procent, aan twee per maand amper 2 procent. De helft van de centra is aan drie per maand na 7,9 maanden of sneller klaar. De inclusie start eind februari 2027, meteen na de Go/No-Go van 23 februari. Twaalf maanden inclusie betekent 144 gerandomiseerd eind februari 2028, zoals het protocol voorziet. Met achttien maanden opvolging valt de laatste visite dan eind augustus 2029, één maand vóór de geplande laatste visite in september. Een eerlijke kanttekening: deze cijfers gaan ervan uit dat elk centrum echt drie per maand haalt. Verschillen de centra onderling, dan is het minder zeker. Daarover gaat de dia na de volgende.</a:t>
             </a:r>
           </a:p>
         </p:txBody>
@@ -20889,7 +20890,7 @@
           <a:lstStyle/>
           <a:p>
             <a:r>
-              <a:t>Tot hier rekenden we alsof elk centrum precies het gemiddelde haalt. Zo werkt het in de praktijk niet: het ene centrum heeft meer geschikte patiënten dan het andere. Een statisticus rekent daarom met centra die onderling verschillen; hier het ene een kwart sneller, het andere een kwart trager dan gemiddeld. De grafiek toont telkens de kans dat alle 144 deelnemers er zijn vóór eind maart 2028, de uiterste datum voor een laatste visite in september 2029, bij een start eind februari 2027, meteen na de Go/No-Go. Aan drie per maand en met centra die even snel zijn is dat 98 procent. Verschillen de centra, dan zakt het naar 65 procent, omdat het traagste centrum de studie ophoudt. Aan twee per maand is het 12 procent, en met verschillen 5 procent. Wat wél helpt, staat al in het risicoplan van de FWO-aanvraag: bijspringen door andere centra. Wie sneller gaat, includeert door, hier tot maximaal 30 per centrum, tot de 144 er zijn. Dan is het aan drie per maand vrijwel zeker, ook als de centra verschillen, en aan twee per maand ongeveer zes kansen op tien. Ons plan is twaalf maanden, eind februari 2028: aan drie per maand is dat 92 procent met even snelle centra, 48 procent als ze verschillen, en 99 procent met bijspringen. Het plan haalt het dus alleen met bijspringen zeker. Bijspringen vraagt wel extra enveloppen per centrum en een afspraak over het plafond; dat leggen we straks ter bespreking voor.</a:t>
+              <a:t>Wat als een centrum twee per maand haalt in plaats van drie? De grafiek toont, maand na maand, hoeveel kans er is dat de inclusie klaar is: de volle lijnen voor één centrum, de streepjeslijnen voor alle zes samen. Blauw is drie per maand, oranje twee. Aan twee per maand duurt het gemiddeld twaalf maanden per centrum, met een spreiding van tweeënhalve maand: acht op tien centra zijn klaar tussen negen en vijftien maanden. Na een jaar is gemiddeld maar de helft van de centra rond, drie van de zes. De studie is pas rond als het traagste centrum klaar is. De geplande laatste visite is september 2029; achttien maanden terug is dat eind maart 2028, de uiterste datum voor de laatste inclusie. We starten eind februari 2027, meteen na de Go/No-Go; dan zijn dat dertien maanden: de verticale lijn. Aan twee per maand halen alle zes die grens maar in 12 procent van de gevallen; aan drie per maand in 98 procent. In de helft van de gevallen is het laatste centrum pas na vijftien maanden klaar, en valt de laatste visite eind november 2029; in één op tien pas in februari 2030. En in acht procent is na achttien maanden nog altijd een centrum niet rond. Dit is gerekend met zes centra die allemaal even snel zijn. Verschillen ze onderling, dan wordt het nog later; dat toont de volgende dia.</a:t>
             </a:r>
           </a:p>
         </p:txBody>
@@ -21029,7 +21030,7 @@
           <a:lstStyle/>
           <a:p>
             <a:r>
-              <a:t>Wat het tempo van uw team vraagt, per maand, en in kleur per visite: onderaan de baseline en de aflevering, daarboven de opvolgvisites van maand drie tot achttien. Links ons voorstel: drie per maand, twaalf maanden inclusie. Dan is het 14 uur per maand zolang de inclusie loopt, met een piek rond maand zeven, en de laatste visite valt rond jun 2029. In het midden en rechts wat achttien maanden inclusie zou geven, aan twee of anderhalve patiënt per maand. Per maand is dat iets minder, rond de elf en tien uur, maar het duurt langer. In totaal is het overal hetzelfde: 300 uur per centrum, want elke patiënt krijgt dezelfde visites. Het verschil zit in het einde. Aan twee per maand valt de laatste visite rond nov 2029, aan anderhalve rond apr 2030: na de geplande laatste visite van september 2029. Dan blijft er voor ons geen tijd om de gegevens te verwerken. Aan anderhalve per maand zijn bovendien maar in 17 procent van de gevallen alle zes centra binnen de achttien maanden rond. De uren zijn die per visite: twee uur in Optimal Care, één uur in Usual Care, twee uur bij de start. Het uitlezen van de MoveMonitor op maand zes valt weg.</a:t>
+              <a:t>Tot hier rekenden we alsof elk centrum precies het gemiddelde haalt. Zo werkt het in de praktijk niet: het ene centrum heeft meer geschikte patiënten dan het andere. Een statisticus rekent daarom met centra die onderling verschillen; hier het ene een kwart sneller, het andere een kwart trager dan gemiddeld. De grafiek toont telkens de kans dat alle 144 deelnemers er zijn vóór eind maart 2028, de uiterste datum voor een laatste visite in september 2029, bij een start eind februari 2027, meteen na de Go/No-Go. Aan drie per maand en met centra die even snel zijn is dat 98 procent. Verschillen de centra, dan zakt het naar 65 procent, omdat het traagste centrum de studie ophoudt. Aan twee per maand is het 12 procent, en met verschillen 5 procent. Wat wél helpt, staat al in het risicoplan van de FWO-aanvraag: bijspringen door andere centra. Wie sneller gaat, includeert door, hier tot maximaal 30 per centrum, tot de 144 er zijn. Dan is het aan drie per maand vrijwel zeker, ook als de centra verschillen, en aan twee per maand ongeveer zes kansen op tien. Ons plan is twaalf maanden, eind februari 2028: aan drie per maand is dat 92 procent met even snelle centra, 48 procent als ze verschillen, en 99 procent met bijspringen. Het plan haalt het dus alleen met bijspringen zeker. Bijspringen vraagt wel extra enveloppen per centrum en een afspraak over het plafond; dat leggen we straks ter bespreking voor.</a:t>
             </a:r>
           </a:p>
         </p:txBody>
@@ -21099,7 +21100,7 @@
           <a:lstStyle/>
           <a:p>
             <a:r>
-              <a:t>Het logo van PARADISE, zoals het nu in alle materiaal staat: de voet als drukbeeld, van koel naar warm, met de P die erin zit. Links het volledige logo op een lichte achtergrond, zoals op de formulieren en het patiëntenmateriaal; in het midden op een donkere achtergrond, zoals in de presentaties en op de website; rechts het symbool alleen, voor klein formaat. Dit is de eerste officiële meeting, dus we vragen uw akkoord: gebruiken we dit logo overal, of wilt u iets aangepast zien?</a:t>
+              <a:t>Wat het tempo van uw team vraagt, per maand, en in kleur per visite: onderaan de baseline en de aflevering, daarboven de opvolgvisites van maand drie tot achttien. Links ons voorstel: drie per maand, twaalf maanden inclusie. Dan is het 14 uur per maand zolang de inclusie loopt, met een piek rond maand zeven, en de laatste visite valt rond jun 2029. In het midden en rechts wat achttien maanden inclusie zou geven, aan twee of anderhalve patiënt per maand. Per maand is dat iets minder, rond de elf en tien uur, maar het duurt langer. In totaal is het overal hetzelfde: 300 uur per centrum, want elke patiënt krijgt dezelfde visites. Het verschil zit in het einde. Aan twee per maand valt de laatste visite rond nov 2029, aan anderhalve rond apr 2030: na de geplande laatste visite van september 2029. Dan blijft er voor ons geen tijd om de gegevens te verwerken. Aan anderhalve per maand zijn bovendien maar in 17 procent van de gevallen alle zes centra binnen de achttien maanden rond. De uren zijn die per visite: twee uur in Optimal Care, één uur in Usual Care, twee uur bij de start. Het uitlezen van de MoveMonitor op maand zes valt weg.</a:t>
             </a:r>
           </a:p>
         </p:txBody>
@@ -21169,7 +21170,7 @@
           <a:lstStyle/>
           <a:p>
             <a:r>
-              <a:t>Links wat we van elk centrum vragen. Eén: drie inclusies per maand, vanaf de start na de Go/No-Go; dan is de inclusie binnen een jaar rond. Twee: een screeningslog vanaf de eerste patiënt, zodat we weten wie overwogen werd en waarom het niet doorging; dat hebben we nodig voor het CONSORT-diagram, en het toont vroeg waar het stokt. Drie: het toetsingsblad terug tegen vrijdag 16 oktober, met per onderwerp optie A of B en de vaste data bevestigd. Vier: wie deelneemt aan de opleidingen, de namen van de podologen en welke artsen de theorie volgen. Vijf: de drukmeting geïnstalleerd vóór uw technologiesessie in december. Rechts twee punten waarover we uw mening vragen. Het eerste: bijspringen. Het risicoplan van de aanvraag voorziet dat andere centra bijspringen als een centrum achterblijft: wie sneller gaat, includeert door tot de 144 er zijn. Daarvoor moeten we afspreken tot hoeveel deelnemers een centrum mag gaan, en zijn er extra enveloppen nodig. Het tweede: twaalf maanden inclusie in plaats van achttien. Dat kost uw team in totaal evenveel uren, alleen sneller; maar met achttien maanden valt de laatste visite in 2030, en dan blijft er voor ons geen tijd voor de verwerking.</a:t>
+              <a:t>Het logo van PARADISE, zoals het nu in alle materiaal staat: de voet als drukbeeld, van koel naar warm, met de P die erin zit. Links het volledige logo op een lichte achtergrond, zoals op de formulieren en het patiëntenmateriaal; in het midden op een donkere achtergrond, zoals in de presentaties en op de website; rechts het symbool alleen, voor klein formaat. Dit is de eerste officiële meeting, dus we vragen uw akkoord: gebruiken we dit logo overal, of wilt u iets aangepast zien?</a:t>
             </a:r>
           </a:p>
         </p:txBody>
@@ -21195,6 +21196,76 @@
 </file>
 
 <file path=ppt/notesSlides/notesSlide23.xml><?xml version="1.0" encoding="utf-8"?>
+<p:notes xmlns:a="http://schemas.openxmlformats.org/drawingml/2006/main" xmlns:p="http://schemas.openxmlformats.org/presentationml/2006/main" xmlns:r="http://schemas.openxmlformats.org/officeDocument/2006/relationships">
+  <p:cSld>
+    <p:spTree>
+      <p:nvGrpSpPr>
+        <p:cNvPr id="1" name=""/>
+        <p:cNvGrpSpPr/>
+        <p:nvPr/>
+      </p:nvGrpSpPr>
+      <p:grpSpPr>
+        <a:xfrm>
+          <a:off x="0" y="0"/>
+          <a:ext cx="0" cy="0"/>
+          <a:chOff x="0" y="0"/>
+          <a:chExt cx="0" cy="0"/>
+        </a:xfrm>
+      </p:grpSpPr>
+      <p:sp>
+        <p:nvSpPr>
+          <p:cNvPr id="2" name="Slide Image Placeholder 1"/>
+          <p:cNvSpPr>
+            <a:spLocks noGrp="1"/>
+          </p:cNvSpPr>
+          <p:nvPr>
+            <p:ph type="sldImg" idx="2"/>
+          </p:nvPr>
+        </p:nvSpPr>
+        <p:spPr/>
+      </p:sp>
+      <p:sp>
+        <p:nvSpPr>
+          <p:cNvPr id="3" name="Notes Placeholder 2"/>
+          <p:cNvSpPr>
+            <a:spLocks noGrp="1"/>
+          </p:cNvSpPr>
+          <p:nvPr>
+            <p:ph type="body" idx="3" sz="quarter"/>
+          </p:nvPr>
+        </p:nvSpPr>
+        <p:spPr/>
+        <p:txBody>
+          <a:bodyPr/>
+          <a:lstStyle/>
+          <a:p>
+            <a:r>
+              <a:t>Links wat we van elk centrum vragen. Eén: drie inclusies per maand, vanaf de start na de Go/No-Go; dan is de inclusie binnen een jaar rond. Twee: een screeningslog vanaf de eerste patiënt, zodat we weten wie overwogen werd en waarom het niet doorging; dat hebben we nodig voor het CONSORT-diagram, en het toont vroeg waar het stokt. Drie: het toetsingsblad terug tegen vrijdag 16 oktober, met per onderwerp optie A of B en de vaste data bevestigd. Vier: wie deelneemt aan de opleidingen, de namen van de podologen en welke artsen de theorie volgen. Vijf: de drukmeting geïnstalleerd vóór uw technologiesessie in december. Rechts twee punten waarover we uw mening vragen. Het eerste: bijspringen. Het risicoplan van de aanvraag voorziet dat andere centra bijspringen als een centrum achterblijft: wie sneller gaat, includeert door tot de 144 er zijn. Daarvoor moeten we afspreken tot hoeveel deelnemers een centrum mag gaan, en zijn er extra enveloppen nodig. Het tweede: twaalf maanden inclusie in plaats van achttien. Dat kost uw team in totaal evenveel uren, alleen sneller; maar met achttien maanden valt de laatste visite in 2030, en dan blijft er voor ons geen tijd voor de verwerking.</a:t>
+            </a:r>
+          </a:p>
+        </p:txBody>
+      </p:sp>
+      <p:sp>
+        <p:nvSpPr>
+          <p:cNvPr id="4" name="Slide Number Placeholder 3"/>
+          <p:cNvSpPr>
+            <a:spLocks noGrp="1"/>
+          </p:cNvSpPr>
+          <p:nvPr>
+            <p:ph type="sldNum" idx="5" sz="quarter"/>
+          </p:nvPr>
+        </p:nvSpPr>
+        <p:spPr/>
+      </p:sp>
+    </p:spTree>
+  </p:cSld>
+  <p:clrMapOvr>
+    <a:masterClrMapping/>
+  </p:clrMapOvr>
+</p:notes>
+</file>
+
+<file path=ppt/notesSlides/notesSlide24.xml><?xml version="1.0" encoding="utf-8"?>
 <p:notes xmlns:a="http://schemas.openxmlformats.org/drawingml/2006/main" xmlns:p="http://schemas.openxmlformats.org/presentationml/2006/main" xmlns:r="http://schemas.openxmlformats.org/officeDocument/2006/relationships">
   <p:cSld>
     <p:spTree>
@@ -38525,6 +38596,1446 @@
 </file>
 
 <file path=ppt/slides/slide16.xml><?xml version="1.0" encoding="utf-8"?>
+<p:sld xmlns:a="http://schemas.openxmlformats.org/drawingml/2006/main" xmlns:p="http://schemas.openxmlformats.org/presentationml/2006/main" xmlns:r="http://schemas.openxmlformats.org/officeDocument/2006/relationships">
+  <p:cSld>
+    <p:bg>
+      <p:bgPr>
+        <a:solidFill>
+          <a:srgbClr val="F2F6F9"/>
+        </a:solidFill>
+        <a:effectLst/>
+      </p:bgPr>
+    </p:bg>
+    <p:spTree>
+      <p:nvGrpSpPr>
+        <p:cNvPr id="1" name=""/>
+        <p:cNvGrpSpPr/>
+        <p:nvPr/>
+      </p:nvGrpSpPr>
+      <p:grpSpPr/>
+      <p:sp>
+        <p:nvSpPr>
+          <p:cNvPr id="2" name="TextBox 1"/>
+          <p:cNvSpPr txBox="1"/>
+          <p:nvPr/>
+        </p:nvSpPr>
+        <p:spPr>
+          <a:xfrm>
+            <a:off x="812800" y="812800"/>
+            <a:ext cx="10617200" cy="198120"/>
+          </a:xfrm>
+          <a:prstGeom prst="rect">
+            <a:avLst/>
+          </a:prstGeom>
+          <a:noFill/>
+        </p:spPr>
+        <p:txBody>
+          <a:bodyPr wrap="none" lIns="0" rIns="0" tIns="0" bIns="0" anchor="t">
+            <a:noAutofit/>
+          </a:bodyPr>
+          <a:lstStyle/>
+          <a:p>
+            <a:pPr algn="l"/>
+            <a:r>
+              <a:rPr sz="1200" b="0" i="0" spc="200">
+                <a:solidFill>
+                  <a:srgbClr val="0B6E8F"/>
+                </a:solidFill>
+                <a:latin typeface="JetBrains Mono"/>
+              </a:rPr>
+              <a:t>5 · PLANNING · SEBIA-OPLEIDING</a:t>
+            </a:r>
+          </a:p>
+        </p:txBody>
+      </p:sp>
+      <p:sp>
+        <p:nvSpPr>
+          <p:cNvPr id="3" name="TextBox 2"/>
+          <p:cNvSpPr txBox="1"/>
+          <p:nvPr/>
+        </p:nvSpPr>
+        <p:spPr>
+          <a:xfrm>
+            <a:off x="812800" y="1111250"/>
+            <a:ext cx="10617200" cy="502920"/>
+          </a:xfrm>
+          <a:prstGeom prst="rect">
+            <a:avLst/>
+          </a:prstGeom>
+          <a:noFill/>
+        </p:spPr>
+        <p:txBody>
+          <a:bodyPr wrap="none" lIns="0" rIns="0" tIns="0" bIns="0" anchor="t">
+            <a:noAutofit/>
+          </a:bodyPr>
+          <a:lstStyle/>
+          <a:p>
+            <a:pPr algn="l">
+              <a:lnSpc>
+                <a:spcPts val="3960"/>
+              </a:lnSpc>
+            </a:pPr>
+            <a:r>
+              <a:rPr sz="3600" b="0" i="0" spc="-50">
+                <a:solidFill>
+                  <a:srgbClr val="0A2540"/>
+                </a:solidFill>
+                <a:latin typeface="DM Serif Display"/>
+              </a:rPr>
+              <a:t>Zes sessies, van educatie naar therapietrouw</a:t>
+            </a:r>
+          </a:p>
+        </p:txBody>
+      </p:sp>
+      <p:sp>
+        <p:nvSpPr>
+          <p:cNvPr id="4" name="TextBox 3"/>
+          <p:cNvSpPr txBox="1"/>
+          <p:nvPr/>
+        </p:nvSpPr>
+        <p:spPr>
+          <a:xfrm>
+            <a:off x="812800" y="1817291"/>
+            <a:ext cx="10617200" cy="257175"/>
+          </a:xfrm>
+          <a:prstGeom prst="rect">
+            <a:avLst/>
+          </a:prstGeom>
+          <a:noFill/>
+        </p:spPr>
+        <p:txBody>
+          <a:bodyPr wrap="none" lIns="0" rIns="0" tIns="0" bIns="0" anchor="t">
+            <a:noAutofit/>
+          </a:bodyPr>
+          <a:lstStyle/>
+          <a:p>
+            <a:pPr algn="l">
+              <a:lnSpc>
+                <a:spcPts val="2025"/>
+              </a:lnSpc>
+            </a:pPr>
+            <a:r>
+              <a:rPr sz="1500" b="0" i="0">
+                <a:solidFill>
+                  <a:srgbClr val="0A2540"/>
+                </a:solidFill>
+                <a:latin typeface="DM Sans"/>
+              </a:rPr>
+              <a:t>Het SEBIA-gesprek komt op elke visite van de PARADISE-arm terug. Fabienne Dobbels leert het de podologen aan.</a:t>
+            </a:r>
+          </a:p>
+        </p:txBody>
+      </p:sp>
+      <p:sp>
+        <p:nvSpPr>
+          <p:cNvPr id="5" name="Rounded Rectangle 4"/>
+          <p:cNvSpPr/>
+          <p:nvPr/>
+        </p:nvSpPr>
+        <p:spPr>
+          <a:xfrm>
+            <a:off x="812800" y="2277666"/>
+            <a:ext cx="2546350" cy="2621161"/>
+          </a:xfrm>
+          <a:prstGeom prst="roundRect">
+            <a:avLst>
+              <a:gd name="adj" fmla="val 4987"/>
+            </a:avLst>
+          </a:prstGeom>
+          <a:solidFill>
+            <a:srgbClr val="FCFDFE"/>
+          </a:solidFill>
+          <a:ln w="6350">
+            <a:solidFill>
+              <a:srgbClr val="D3DFE8"/>
+            </a:solidFill>
+          </a:ln>
+          <a:effectLst/>
+        </p:spPr>
+        <p:style>
+          <a:lnRef idx="1">
+            <a:schemeClr val="accent1"/>
+          </a:lnRef>
+          <a:fillRef idx="3">
+            <a:schemeClr val="accent1"/>
+          </a:fillRef>
+          <a:effectRef idx="2">
+            <a:schemeClr val="accent1"/>
+          </a:effectRef>
+          <a:fontRef idx="minor">
+            <a:schemeClr val="lt1"/>
+          </a:fontRef>
+        </p:style>
+        <p:txBody>
+          <a:bodyPr rtlCol="0" anchor="ctr"/>
+          <a:lstStyle/>
+          <a:p/>
+        </p:txBody>
+      </p:sp>
+      <p:sp>
+        <p:nvSpPr>
+          <p:cNvPr id="6" name="TextBox 5"/>
+          <p:cNvSpPr txBox="1"/>
+          <p:nvPr/>
+        </p:nvSpPr>
+        <p:spPr>
+          <a:xfrm>
+            <a:off x="996950" y="2449116"/>
+            <a:ext cx="2228850" cy="184150"/>
+          </a:xfrm>
+          <a:prstGeom prst="rect">
+            <a:avLst/>
+          </a:prstGeom>
+          <a:noFill/>
+        </p:spPr>
+        <p:txBody>
+          <a:bodyPr wrap="none" lIns="0" rIns="0" tIns="0" bIns="0" anchor="t">
+            <a:noAutofit/>
+          </a:bodyPr>
+          <a:lstStyle/>
+          <a:p>
+            <a:pPr algn="l"/>
+            <a:r>
+              <a:rPr sz="1100" b="0" i="0" spc="100">
+                <a:solidFill>
+                  <a:srgbClr val="0B6E8F"/>
+                </a:solidFill>
+                <a:latin typeface="JetBrains Mono"/>
+              </a:rPr>
+              <a:t>JANUARI · 4 U</a:t>
+            </a:r>
+          </a:p>
+        </p:txBody>
+      </p:sp>
+      <p:sp>
+        <p:nvSpPr>
+          <p:cNvPr id="7" name="TextBox 6"/>
+          <p:cNvSpPr txBox="1"/>
+          <p:nvPr/>
+        </p:nvSpPr>
+        <p:spPr>
+          <a:xfrm>
+            <a:off x="996950" y="2696766"/>
+            <a:ext cx="2228850" cy="406400"/>
+          </a:xfrm>
+          <a:prstGeom prst="rect">
+            <a:avLst/>
+          </a:prstGeom>
+          <a:noFill/>
+        </p:spPr>
+        <p:txBody>
+          <a:bodyPr wrap="none" lIns="0" rIns="0" tIns="0" bIns="0" anchor="t">
+            <a:noAutofit/>
+          </a:bodyPr>
+          <a:lstStyle/>
+          <a:p>
+            <a:pPr algn="l">
+              <a:lnSpc>
+                <a:spcPts val="3200"/>
+              </a:lnSpc>
+            </a:pPr>
+            <a:r>
+              <a:rPr sz="3200" b="0" i="0">
+                <a:solidFill>
+                  <a:srgbClr val="0A2540"/>
+                </a:solidFill>
+                <a:latin typeface="DM Serif Display"/>
+              </a:rPr>
+              <a:t>1 + 2</a:t>
+            </a:r>
+          </a:p>
+        </p:txBody>
+      </p:sp>
+      <p:sp>
+        <p:nvSpPr>
+          <p:cNvPr id="8" name="TextBox 7"/>
+          <p:cNvSpPr txBox="1"/>
+          <p:nvPr/>
+        </p:nvSpPr>
+        <p:spPr>
+          <a:xfrm>
+            <a:off x="996950" y="3166666"/>
+            <a:ext cx="2228850" cy="222250"/>
+          </a:xfrm>
+          <a:prstGeom prst="rect">
+            <a:avLst/>
+          </a:prstGeom>
+          <a:noFill/>
+        </p:spPr>
+        <p:txBody>
+          <a:bodyPr wrap="none" lIns="0" rIns="0" tIns="0" bIns="0" anchor="t">
+            <a:noAutofit/>
+          </a:bodyPr>
+          <a:lstStyle/>
+          <a:p>
+            <a:pPr algn="l">
+              <a:lnSpc>
+                <a:spcPts val="1750"/>
+              </a:lnSpc>
+            </a:pPr>
+            <a:r>
+              <a:rPr sz="1400" b="1" i="0">
+                <a:solidFill>
+                  <a:srgbClr val="0A2540"/>
+                </a:solidFill>
+                <a:latin typeface="DM Sans"/>
+              </a:rPr>
+              <a:t>Educatie en feedback</a:t>
+            </a:r>
+          </a:p>
+        </p:txBody>
+      </p:sp>
+      <p:sp>
+        <p:nvSpPr>
+          <p:cNvPr id="9" name="TextBox 8"/>
+          <p:cNvSpPr txBox="1"/>
+          <p:nvPr/>
+        </p:nvSpPr>
+        <p:spPr>
+          <a:xfrm>
+            <a:off x="996950" y="3452416"/>
+            <a:ext cx="2228850" cy="883841"/>
+          </a:xfrm>
+          <a:prstGeom prst="rect">
+            <a:avLst/>
+          </a:prstGeom>
+          <a:noFill/>
+        </p:spPr>
+        <p:txBody>
+          <a:bodyPr wrap="square" lIns="0" rIns="0" tIns="0" bIns="0" anchor="t">
+            <a:noAutofit/>
+          </a:bodyPr>
+          <a:lstStyle/>
+          <a:p>
+            <a:pPr algn="l">
+              <a:lnSpc>
+                <a:spcPts val="1739"/>
+              </a:lnSpc>
+            </a:pPr>
+            <a:r>
+              <a:rPr sz="1200" b="0" i="0">
+                <a:solidFill>
+                  <a:srgbClr val="3A4F63"/>
+                </a:solidFill>
+                <a:latin typeface="DM Sans"/>
+              </a:rPr>
+              <a:t>teach-back en show-me</a:t>
+            </a:r>
+          </a:p>
+          <a:p>
+            <a:pPr algn="l">
+              <a:lnSpc>
+                <a:spcPts val="1739"/>
+              </a:lnSpc>
+            </a:pPr>
+            <a:r>
+              <a:rPr sz="1200" b="0" i="0">
+                <a:solidFill>
+                  <a:srgbClr val="3A4F63"/>
+                </a:solidFill>
+                <a:latin typeface="DM Sans"/>
+              </a:rPr>
+              <a:t>voetzorg voordoen</a:t>
+            </a:r>
+          </a:p>
+          <a:p>
+            <a:pPr algn="l">
+              <a:lnSpc>
+                <a:spcPts val="1739"/>
+              </a:lnSpc>
+            </a:pPr>
+            <a:r>
+              <a:rPr sz="1200" b="0" i="0">
+                <a:solidFill>
+                  <a:srgbClr val="3A4F63"/>
+                </a:solidFill>
+                <a:latin typeface="DM Sans"/>
+              </a:rPr>
+              <a:t>kennis toetsen (NAFF)</a:t>
+            </a:r>
+          </a:p>
+          <a:p>
+            <a:pPr algn="l">
+              <a:lnSpc>
+                <a:spcPts val="1739"/>
+              </a:lnSpc>
+            </a:pPr>
+            <a:r>
+              <a:rPr sz="1200" b="0" i="0">
+                <a:solidFill>
+                  <a:srgbClr val="3A4F63"/>
+                </a:solidFill>
+                <a:latin typeface="DM Sans"/>
+              </a:rPr>
+              <a:t>feedback op de draagtijd</a:t>
+            </a:r>
+          </a:p>
+        </p:txBody>
+      </p:sp>
+      <p:sp>
+        <p:nvSpPr>
+          <p:cNvPr id="10" name="Rectangle 9"/>
+          <p:cNvSpPr/>
+          <p:nvPr/>
+        </p:nvSpPr>
+        <p:spPr>
+          <a:xfrm>
+            <a:off x="996950" y="4463256"/>
+            <a:ext cx="2178050" cy="6350"/>
+          </a:xfrm>
+          <a:prstGeom prst="rect">
+            <a:avLst/>
+          </a:prstGeom>
+          <a:solidFill>
+            <a:srgbClr val="D3DFE8"/>
+          </a:solidFill>
+          <a:ln>
+            <a:noFill/>
+          </a:ln>
+          <a:effectLst/>
+        </p:spPr>
+        <p:style>
+          <a:lnRef idx="1">
+            <a:schemeClr val="accent1"/>
+          </a:lnRef>
+          <a:fillRef idx="3">
+            <a:schemeClr val="accent1"/>
+          </a:fillRef>
+          <a:effectRef idx="2">
+            <a:schemeClr val="accent1"/>
+          </a:effectRef>
+          <a:fontRef idx="minor">
+            <a:schemeClr val="lt1"/>
+          </a:fontRef>
+        </p:style>
+        <p:txBody>
+          <a:bodyPr rtlCol="0" anchor="ctr"/>
+          <a:lstStyle/>
+          <a:p>
+            <a:pPr algn="ctr"/>
+          </a:p>
+        </p:txBody>
+      </p:sp>
+      <p:sp>
+        <p:nvSpPr>
+          <p:cNvPr id="11" name="TextBox 10"/>
+          <p:cNvSpPr txBox="1"/>
+          <p:nvPr/>
+        </p:nvSpPr>
+        <p:spPr>
+          <a:xfrm>
+            <a:off x="996950" y="4545806"/>
+            <a:ext cx="2228850" cy="181610"/>
+          </a:xfrm>
+          <a:prstGeom prst="rect">
+            <a:avLst/>
+          </a:prstGeom>
+          <a:noFill/>
+        </p:spPr>
+        <p:txBody>
+          <a:bodyPr wrap="none" lIns="0" rIns="0" tIns="0" bIns="0" anchor="t">
+            <a:noAutofit/>
+          </a:bodyPr>
+          <a:lstStyle/>
+          <a:p>
+            <a:pPr algn="l">
+              <a:lnSpc>
+                <a:spcPts val="1430"/>
+              </a:lnSpc>
+            </a:pPr>
+            <a:r>
+              <a:rPr sz="1100" b="0" i="0">
+                <a:solidFill>
+                  <a:srgbClr val="5A6E80"/>
+                </a:solidFill>
+                <a:latin typeface="DM Sans"/>
+              </a:rPr>
+              <a:t>overdag, drie groepen</a:t>
+            </a:r>
+          </a:p>
+        </p:txBody>
+      </p:sp>
+      <p:sp>
+        <p:nvSpPr>
+          <p:cNvPr id="12" name="Rounded Rectangle 11"/>
+          <p:cNvSpPr/>
+          <p:nvPr/>
+        </p:nvSpPr>
+        <p:spPr>
+          <a:xfrm>
+            <a:off x="3486150" y="2277666"/>
+            <a:ext cx="2546350" cy="2621161"/>
+          </a:xfrm>
+          <a:prstGeom prst="roundRect">
+            <a:avLst>
+              <a:gd name="adj" fmla="val 4987"/>
+            </a:avLst>
+          </a:prstGeom>
+          <a:solidFill>
+            <a:srgbClr val="FCFDFE"/>
+          </a:solidFill>
+          <a:ln w="6350">
+            <a:solidFill>
+              <a:srgbClr val="D3DFE8"/>
+            </a:solidFill>
+          </a:ln>
+          <a:effectLst/>
+        </p:spPr>
+        <p:style>
+          <a:lnRef idx="1">
+            <a:schemeClr val="accent1"/>
+          </a:lnRef>
+          <a:fillRef idx="3">
+            <a:schemeClr val="accent1"/>
+          </a:fillRef>
+          <a:effectRef idx="2">
+            <a:schemeClr val="accent1"/>
+          </a:effectRef>
+          <a:fontRef idx="minor">
+            <a:schemeClr val="lt1"/>
+          </a:fontRef>
+        </p:style>
+        <p:txBody>
+          <a:bodyPr rtlCol="0" anchor="ctr"/>
+          <a:lstStyle/>
+          <a:p/>
+        </p:txBody>
+      </p:sp>
+      <p:sp>
+        <p:nvSpPr>
+          <p:cNvPr id="13" name="TextBox 12"/>
+          <p:cNvSpPr txBox="1"/>
+          <p:nvPr/>
+        </p:nvSpPr>
+        <p:spPr>
+          <a:xfrm>
+            <a:off x="3670300" y="2449116"/>
+            <a:ext cx="2228850" cy="184150"/>
+          </a:xfrm>
+          <a:prstGeom prst="rect">
+            <a:avLst/>
+          </a:prstGeom>
+          <a:noFill/>
+        </p:spPr>
+        <p:txBody>
+          <a:bodyPr wrap="none" lIns="0" rIns="0" tIns="0" bIns="0" anchor="t">
+            <a:noAutofit/>
+          </a:bodyPr>
+          <a:lstStyle/>
+          <a:p>
+            <a:pPr algn="l"/>
+            <a:r>
+              <a:rPr sz="1100" b="0" i="0" spc="100">
+                <a:solidFill>
+                  <a:srgbClr val="0B6E8F"/>
+                </a:solidFill>
+                <a:latin typeface="JetBrains Mono"/>
+              </a:rPr>
+              <a:t>MAART · 4 U</a:t>
+            </a:r>
+          </a:p>
+        </p:txBody>
+      </p:sp>
+      <p:sp>
+        <p:nvSpPr>
+          <p:cNvPr id="14" name="TextBox 13"/>
+          <p:cNvSpPr txBox="1"/>
+          <p:nvPr/>
+        </p:nvSpPr>
+        <p:spPr>
+          <a:xfrm>
+            <a:off x="3670300" y="2696766"/>
+            <a:ext cx="2228850" cy="406400"/>
+          </a:xfrm>
+          <a:prstGeom prst="rect">
+            <a:avLst/>
+          </a:prstGeom>
+          <a:noFill/>
+        </p:spPr>
+        <p:txBody>
+          <a:bodyPr wrap="none" lIns="0" rIns="0" tIns="0" bIns="0" anchor="t">
+            <a:noAutofit/>
+          </a:bodyPr>
+          <a:lstStyle/>
+          <a:p>
+            <a:pPr algn="l">
+              <a:lnSpc>
+                <a:spcPts val="3200"/>
+              </a:lnSpc>
+            </a:pPr>
+            <a:r>
+              <a:rPr sz="3200" b="0" i="0">
+                <a:solidFill>
+                  <a:srgbClr val="0A2540"/>
+                </a:solidFill>
+                <a:latin typeface="DM Serif Display"/>
+              </a:rPr>
+              <a:t>3 + 4</a:t>
+            </a:r>
+          </a:p>
+        </p:txBody>
+      </p:sp>
+      <p:sp>
+        <p:nvSpPr>
+          <p:cNvPr id="15" name="TextBox 14"/>
+          <p:cNvSpPr txBox="1"/>
+          <p:nvPr/>
+        </p:nvSpPr>
+        <p:spPr>
+          <a:xfrm>
+            <a:off x="3670300" y="3166666"/>
+            <a:ext cx="2228850" cy="444500"/>
+          </a:xfrm>
+          <a:prstGeom prst="rect">
+            <a:avLst/>
+          </a:prstGeom>
+          <a:noFill/>
+        </p:spPr>
+        <p:txBody>
+          <a:bodyPr wrap="square" lIns="0" rIns="0" tIns="0" bIns="0" anchor="t">
+            <a:noAutofit/>
+          </a:bodyPr>
+          <a:lstStyle/>
+          <a:p>
+            <a:pPr algn="l">
+              <a:lnSpc>
+                <a:spcPts val="1750"/>
+              </a:lnSpc>
+            </a:pPr>
+            <a:r>
+              <a:rPr sz="1400" b="1" i="0">
+                <a:solidFill>
+                  <a:srgbClr val="0A2540"/>
+                </a:solidFill>
+                <a:latin typeface="DM Sans"/>
+              </a:rPr>
+              <a:t>Motiverende gespreksvoering</a:t>
+            </a:r>
+          </a:p>
+        </p:txBody>
+      </p:sp>
+      <p:sp>
+        <p:nvSpPr>
+          <p:cNvPr id="16" name="TextBox 15"/>
+          <p:cNvSpPr txBox="1"/>
+          <p:nvPr/>
+        </p:nvSpPr>
+        <p:spPr>
+          <a:xfrm>
+            <a:off x="3670300" y="3674666"/>
+            <a:ext cx="2228850" cy="441920"/>
+          </a:xfrm>
+          <a:prstGeom prst="rect">
+            <a:avLst/>
+          </a:prstGeom>
+          <a:noFill/>
+        </p:spPr>
+        <p:txBody>
+          <a:bodyPr wrap="square" lIns="0" rIns="0" tIns="0" bIns="0" anchor="t">
+            <a:noAutofit/>
+          </a:bodyPr>
+          <a:lstStyle/>
+          <a:p>
+            <a:pPr algn="l">
+              <a:lnSpc>
+                <a:spcPts val="1739"/>
+              </a:lnSpc>
+            </a:pPr>
+            <a:r>
+              <a:rPr sz="1200" b="0" i="0">
+                <a:solidFill>
+                  <a:srgbClr val="3A4F63"/>
+                </a:solidFill>
+                <a:latin typeface="DM Sans"/>
+              </a:rPr>
+              <a:t>motivatie inschatten</a:t>
+            </a:r>
+          </a:p>
+          <a:p>
+            <a:pPr algn="l">
+              <a:lnSpc>
+                <a:spcPts val="1739"/>
+              </a:lnSpc>
+            </a:pPr>
+            <a:r>
+              <a:rPr sz="1200" b="0" i="0">
+                <a:solidFill>
+                  <a:srgbClr val="3A4F63"/>
+                </a:solidFill>
+                <a:latin typeface="DM Sans"/>
+              </a:rPr>
+              <a:t>interventie op maat</a:t>
+            </a:r>
+          </a:p>
+        </p:txBody>
+      </p:sp>
+      <p:sp>
+        <p:nvSpPr>
+          <p:cNvPr id="17" name="Rectangle 16"/>
+          <p:cNvSpPr/>
+          <p:nvPr/>
+        </p:nvSpPr>
+        <p:spPr>
+          <a:xfrm>
+            <a:off x="3670300" y="4463256"/>
+            <a:ext cx="2178050" cy="6350"/>
+          </a:xfrm>
+          <a:prstGeom prst="rect">
+            <a:avLst/>
+          </a:prstGeom>
+          <a:solidFill>
+            <a:srgbClr val="D3DFE8"/>
+          </a:solidFill>
+          <a:ln>
+            <a:noFill/>
+          </a:ln>
+          <a:effectLst/>
+        </p:spPr>
+        <p:style>
+          <a:lnRef idx="1">
+            <a:schemeClr val="accent1"/>
+          </a:lnRef>
+          <a:fillRef idx="3">
+            <a:schemeClr val="accent1"/>
+          </a:fillRef>
+          <a:effectRef idx="2">
+            <a:schemeClr val="accent1"/>
+          </a:effectRef>
+          <a:fontRef idx="minor">
+            <a:schemeClr val="lt1"/>
+          </a:fontRef>
+        </p:style>
+        <p:txBody>
+          <a:bodyPr rtlCol="0" anchor="ctr"/>
+          <a:lstStyle/>
+          <a:p>
+            <a:pPr algn="ctr"/>
+          </a:p>
+        </p:txBody>
+      </p:sp>
+      <p:sp>
+        <p:nvSpPr>
+          <p:cNvPr id="18" name="TextBox 17"/>
+          <p:cNvSpPr txBox="1"/>
+          <p:nvPr/>
+        </p:nvSpPr>
+        <p:spPr>
+          <a:xfrm>
+            <a:off x="3670300" y="4545806"/>
+            <a:ext cx="2228850" cy="181610"/>
+          </a:xfrm>
+          <a:prstGeom prst="rect">
+            <a:avLst/>
+          </a:prstGeom>
+          <a:noFill/>
+        </p:spPr>
+        <p:txBody>
+          <a:bodyPr wrap="none" lIns="0" rIns="0" tIns="0" bIns="0" anchor="t">
+            <a:noAutofit/>
+          </a:bodyPr>
+          <a:lstStyle/>
+          <a:p>
+            <a:pPr algn="l">
+              <a:lnSpc>
+                <a:spcPts val="1430"/>
+              </a:lnSpc>
+            </a:pPr>
+            <a:r>
+              <a:rPr sz="1100" b="0" i="0">
+                <a:solidFill>
+                  <a:srgbClr val="5A6E80"/>
+                </a:solidFill>
+                <a:latin typeface="DM Sans"/>
+              </a:rPr>
+              <a:t>overdag, drie groepen (voorstel)</a:t>
+            </a:r>
+          </a:p>
+        </p:txBody>
+      </p:sp>
+      <p:sp>
+        <p:nvSpPr>
+          <p:cNvPr id="19" name="Rounded Rectangle 18"/>
+          <p:cNvSpPr/>
+          <p:nvPr/>
+        </p:nvSpPr>
+        <p:spPr>
+          <a:xfrm>
+            <a:off x="6159500" y="2277666"/>
+            <a:ext cx="2546350" cy="2621161"/>
+          </a:xfrm>
+          <a:prstGeom prst="roundRect">
+            <a:avLst>
+              <a:gd name="adj" fmla="val 4987"/>
+            </a:avLst>
+          </a:prstGeom>
+          <a:solidFill>
+            <a:srgbClr val="FCFDFE"/>
+          </a:solidFill>
+          <a:ln w="6350">
+            <a:solidFill>
+              <a:srgbClr val="D3DFE8"/>
+            </a:solidFill>
+          </a:ln>
+          <a:effectLst/>
+        </p:spPr>
+        <p:style>
+          <a:lnRef idx="1">
+            <a:schemeClr val="accent1"/>
+          </a:lnRef>
+          <a:fillRef idx="3">
+            <a:schemeClr val="accent1"/>
+          </a:fillRef>
+          <a:effectRef idx="2">
+            <a:schemeClr val="accent1"/>
+          </a:effectRef>
+          <a:fontRef idx="minor">
+            <a:schemeClr val="lt1"/>
+          </a:fontRef>
+        </p:style>
+        <p:txBody>
+          <a:bodyPr rtlCol="0" anchor="ctr"/>
+          <a:lstStyle/>
+          <a:p/>
+        </p:txBody>
+      </p:sp>
+      <p:sp>
+        <p:nvSpPr>
+          <p:cNvPr id="20" name="TextBox 19"/>
+          <p:cNvSpPr txBox="1"/>
+          <p:nvPr/>
+        </p:nvSpPr>
+        <p:spPr>
+          <a:xfrm>
+            <a:off x="6343650" y="2449116"/>
+            <a:ext cx="2228850" cy="184150"/>
+          </a:xfrm>
+          <a:prstGeom prst="rect">
+            <a:avLst/>
+          </a:prstGeom>
+          <a:noFill/>
+        </p:spPr>
+        <p:txBody>
+          <a:bodyPr wrap="none" lIns="0" rIns="0" tIns="0" bIns="0" anchor="t">
+            <a:noAutofit/>
+          </a:bodyPr>
+          <a:lstStyle/>
+          <a:p>
+            <a:pPr algn="l"/>
+            <a:r>
+              <a:rPr sz="1100" b="0" i="0" spc="100">
+                <a:solidFill>
+                  <a:srgbClr val="0B6E8F"/>
+                </a:solidFill>
+                <a:latin typeface="JetBrains Mono"/>
+              </a:rPr>
+              <a:t>15–26 MAART · 1,5 U</a:t>
+            </a:r>
+          </a:p>
+        </p:txBody>
+      </p:sp>
+      <p:sp>
+        <p:nvSpPr>
+          <p:cNvPr id="21" name="TextBox 20"/>
+          <p:cNvSpPr txBox="1"/>
+          <p:nvPr/>
+        </p:nvSpPr>
+        <p:spPr>
+          <a:xfrm>
+            <a:off x="6343650" y="2696766"/>
+            <a:ext cx="2228850" cy="406400"/>
+          </a:xfrm>
+          <a:prstGeom prst="rect">
+            <a:avLst/>
+          </a:prstGeom>
+          <a:noFill/>
+        </p:spPr>
+        <p:txBody>
+          <a:bodyPr wrap="none" lIns="0" rIns="0" tIns="0" bIns="0" anchor="t">
+            <a:noAutofit/>
+          </a:bodyPr>
+          <a:lstStyle/>
+          <a:p>
+            <a:pPr algn="l">
+              <a:lnSpc>
+                <a:spcPts val="3200"/>
+              </a:lnSpc>
+            </a:pPr>
+            <a:r>
+              <a:rPr sz="3200" b="0" i="0">
+                <a:solidFill>
+                  <a:srgbClr val="0A2540"/>
+                </a:solidFill>
+                <a:latin typeface="DM Serif Display"/>
+              </a:rPr>
+              <a:t>5</a:t>
+            </a:r>
+          </a:p>
+        </p:txBody>
+      </p:sp>
+      <p:sp>
+        <p:nvSpPr>
+          <p:cNvPr id="22" name="TextBox 21"/>
+          <p:cNvSpPr txBox="1"/>
+          <p:nvPr/>
+        </p:nvSpPr>
+        <p:spPr>
+          <a:xfrm>
+            <a:off x="6343650" y="3166666"/>
+            <a:ext cx="2228850" cy="222250"/>
+          </a:xfrm>
+          <a:prstGeom prst="rect">
+            <a:avLst/>
+          </a:prstGeom>
+          <a:noFill/>
+        </p:spPr>
+        <p:txBody>
+          <a:bodyPr wrap="none" lIns="0" rIns="0" tIns="0" bIns="0" anchor="t">
+            <a:noAutofit/>
+          </a:bodyPr>
+          <a:lstStyle/>
+          <a:p>
+            <a:pPr algn="l">
+              <a:lnSpc>
+                <a:spcPts val="1750"/>
+              </a:lnSpc>
+            </a:pPr>
+            <a:r>
+              <a:rPr sz="1400" b="1" i="0">
+                <a:solidFill>
+                  <a:srgbClr val="0A2540"/>
+                </a:solidFill>
+                <a:latin typeface="DM Sans"/>
+              </a:rPr>
+              <a:t>Oefenen</a:t>
+            </a:r>
+          </a:p>
+        </p:txBody>
+      </p:sp>
+      <p:sp>
+        <p:nvSpPr>
+          <p:cNvPr id="23" name="TextBox 22"/>
+          <p:cNvSpPr txBox="1"/>
+          <p:nvPr/>
+        </p:nvSpPr>
+        <p:spPr>
+          <a:xfrm>
+            <a:off x="6343650" y="3452416"/>
+            <a:ext cx="2228850" cy="220980"/>
+          </a:xfrm>
+          <a:prstGeom prst="rect">
+            <a:avLst/>
+          </a:prstGeom>
+          <a:noFill/>
+        </p:spPr>
+        <p:txBody>
+          <a:bodyPr wrap="none" lIns="0" rIns="0" tIns="0" bIns="0" anchor="t">
+            <a:noAutofit/>
+          </a:bodyPr>
+          <a:lstStyle/>
+          <a:p>
+            <a:pPr algn="l">
+              <a:lnSpc>
+                <a:spcPts val="1739"/>
+              </a:lnSpc>
+            </a:pPr>
+            <a:r>
+              <a:rPr sz="1200" b="0" i="0">
+                <a:solidFill>
+                  <a:srgbClr val="3A4F63"/>
+                </a:solidFill>
+                <a:latin typeface="DM Sans"/>
+              </a:rPr>
+              <a:t>rollenspel met de scripts</a:t>
+            </a:r>
+          </a:p>
+        </p:txBody>
+      </p:sp>
+      <p:sp>
+        <p:nvSpPr>
+          <p:cNvPr id="24" name="Rectangle 23"/>
+          <p:cNvSpPr/>
+          <p:nvPr/>
+        </p:nvSpPr>
+        <p:spPr>
+          <a:xfrm>
+            <a:off x="6343650" y="4463256"/>
+            <a:ext cx="2178050" cy="6350"/>
+          </a:xfrm>
+          <a:prstGeom prst="rect">
+            <a:avLst/>
+          </a:prstGeom>
+          <a:solidFill>
+            <a:srgbClr val="D3DFE8"/>
+          </a:solidFill>
+          <a:ln>
+            <a:noFill/>
+          </a:ln>
+          <a:effectLst/>
+        </p:spPr>
+        <p:style>
+          <a:lnRef idx="1">
+            <a:schemeClr val="accent1"/>
+          </a:lnRef>
+          <a:fillRef idx="3">
+            <a:schemeClr val="accent1"/>
+          </a:fillRef>
+          <a:effectRef idx="2">
+            <a:schemeClr val="accent1"/>
+          </a:effectRef>
+          <a:fontRef idx="minor">
+            <a:schemeClr val="lt1"/>
+          </a:fontRef>
+        </p:style>
+        <p:txBody>
+          <a:bodyPr rtlCol="0" anchor="ctr"/>
+          <a:lstStyle/>
+          <a:p>
+            <a:pPr algn="ctr"/>
+          </a:p>
+        </p:txBody>
+      </p:sp>
+      <p:sp>
+        <p:nvSpPr>
+          <p:cNvPr id="25" name="TextBox 24"/>
+          <p:cNvSpPr txBox="1"/>
+          <p:nvPr/>
+        </p:nvSpPr>
+        <p:spPr>
+          <a:xfrm>
+            <a:off x="6343650" y="4545806"/>
+            <a:ext cx="2228850" cy="181610"/>
+          </a:xfrm>
+          <a:prstGeom prst="rect">
+            <a:avLst/>
+          </a:prstGeom>
+          <a:noFill/>
+        </p:spPr>
+        <p:txBody>
+          <a:bodyPr wrap="none" lIns="0" rIns="0" tIns="0" bIns="0" anchor="t">
+            <a:noAutofit/>
+          </a:bodyPr>
+          <a:lstStyle/>
+          <a:p>
+            <a:pPr algn="l">
+              <a:lnSpc>
+                <a:spcPts val="1430"/>
+              </a:lnSpc>
+            </a:pPr>
+            <a:r>
+              <a:rPr sz="1100" b="0" i="0">
+                <a:solidFill>
+                  <a:srgbClr val="5A6E80"/>
+                </a:solidFill>
+                <a:latin typeface="DM Sans"/>
+              </a:rPr>
+              <a:t>in uw centrum, individueel</a:t>
+            </a:r>
+          </a:p>
+        </p:txBody>
+      </p:sp>
+      <p:sp>
+        <p:nvSpPr>
+          <p:cNvPr id="26" name="Rounded Rectangle 25"/>
+          <p:cNvSpPr/>
+          <p:nvPr/>
+        </p:nvSpPr>
+        <p:spPr>
+          <a:xfrm>
+            <a:off x="8832850" y="2277666"/>
+            <a:ext cx="2546350" cy="2621161"/>
+          </a:xfrm>
+          <a:prstGeom prst="roundRect">
+            <a:avLst>
+              <a:gd name="adj" fmla="val 4987"/>
+            </a:avLst>
+          </a:prstGeom>
+          <a:solidFill>
+            <a:srgbClr val="FCFDFE"/>
+          </a:solidFill>
+          <a:ln w="6350">
+            <a:solidFill>
+              <a:srgbClr val="D3DFE8"/>
+            </a:solidFill>
+          </a:ln>
+          <a:effectLst/>
+        </p:spPr>
+        <p:style>
+          <a:lnRef idx="1">
+            <a:schemeClr val="accent1"/>
+          </a:lnRef>
+          <a:fillRef idx="3">
+            <a:schemeClr val="accent1"/>
+          </a:fillRef>
+          <a:effectRef idx="2">
+            <a:schemeClr val="accent1"/>
+          </a:effectRef>
+          <a:fontRef idx="minor">
+            <a:schemeClr val="lt1"/>
+          </a:fontRef>
+        </p:style>
+        <p:txBody>
+          <a:bodyPr rtlCol="0" anchor="ctr"/>
+          <a:lstStyle/>
+          <a:p/>
+        </p:txBody>
+      </p:sp>
+      <p:sp>
+        <p:nvSpPr>
+          <p:cNvPr id="27" name="TextBox 26"/>
+          <p:cNvSpPr txBox="1"/>
+          <p:nvPr/>
+        </p:nvSpPr>
+        <p:spPr>
+          <a:xfrm>
+            <a:off x="9017000" y="2449116"/>
+            <a:ext cx="2228850" cy="184150"/>
+          </a:xfrm>
+          <a:prstGeom prst="rect">
+            <a:avLst/>
+          </a:prstGeom>
+          <a:noFill/>
+        </p:spPr>
+        <p:txBody>
+          <a:bodyPr wrap="none" lIns="0" rIns="0" tIns="0" bIns="0" anchor="t">
+            <a:noAutofit/>
+          </a:bodyPr>
+          <a:lstStyle/>
+          <a:p>
+            <a:pPr algn="l"/>
+            <a:r>
+              <a:rPr sz="1100" b="0" i="0" spc="100">
+                <a:solidFill>
+                  <a:srgbClr val="0B6E8F"/>
+                </a:solidFill>
+                <a:latin typeface="JetBrains Mono"/>
+              </a:rPr>
+              <a:t>SEP–NOV 2027 · 1 U</a:t>
+            </a:r>
+          </a:p>
+        </p:txBody>
+      </p:sp>
+      <p:sp>
+        <p:nvSpPr>
+          <p:cNvPr id="28" name="TextBox 27"/>
+          <p:cNvSpPr txBox="1"/>
+          <p:nvPr/>
+        </p:nvSpPr>
+        <p:spPr>
+          <a:xfrm>
+            <a:off x="9017000" y="2696766"/>
+            <a:ext cx="2228850" cy="406400"/>
+          </a:xfrm>
+          <a:prstGeom prst="rect">
+            <a:avLst/>
+          </a:prstGeom>
+          <a:noFill/>
+        </p:spPr>
+        <p:txBody>
+          <a:bodyPr wrap="none" lIns="0" rIns="0" tIns="0" bIns="0" anchor="t">
+            <a:noAutofit/>
+          </a:bodyPr>
+          <a:lstStyle/>
+          <a:p>
+            <a:pPr algn="l">
+              <a:lnSpc>
+                <a:spcPts val="3200"/>
+              </a:lnSpc>
+            </a:pPr>
+            <a:r>
+              <a:rPr sz="3200" b="0" i="0">
+                <a:solidFill>
+                  <a:srgbClr val="0A2540"/>
+                </a:solidFill>
+                <a:latin typeface="DM Serif Display"/>
+              </a:rPr>
+              <a:t>6</a:t>
+            </a:r>
+          </a:p>
+        </p:txBody>
+      </p:sp>
+      <p:sp>
+        <p:nvSpPr>
+          <p:cNvPr id="29" name="TextBox 28"/>
+          <p:cNvSpPr txBox="1"/>
+          <p:nvPr/>
+        </p:nvSpPr>
+        <p:spPr>
+          <a:xfrm>
+            <a:off x="9017000" y="3166666"/>
+            <a:ext cx="2228850" cy="222250"/>
+          </a:xfrm>
+          <a:prstGeom prst="rect">
+            <a:avLst/>
+          </a:prstGeom>
+          <a:noFill/>
+        </p:spPr>
+        <p:txBody>
+          <a:bodyPr wrap="none" lIns="0" rIns="0" tIns="0" bIns="0" anchor="t">
+            <a:noAutofit/>
+          </a:bodyPr>
+          <a:lstStyle/>
+          <a:p>
+            <a:pPr algn="l">
+              <a:lnSpc>
+                <a:spcPts val="1750"/>
+              </a:lnSpc>
+            </a:pPr>
+            <a:r>
+              <a:rPr sz="1400" b="1" i="0">
+                <a:solidFill>
+                  <a:srgbClr val="0A2540"/>
+                </a:solidFill>
+                <a:latin typeface="DM Sans"/>
+              </a:rPr>
+              <a:t>Intervisie</a:t>
+            </a:r>
+          </a:p>
+        </p:txBody>
+      </p:sp>
+      <p:sp>
+        <p:nvSpPr>
+          <p:cNvPr id="30" name="TextBox 29"/>
+          <p:cNvSpPr txBox="1"/>
+          <p:nvPr/>
+        </p:nvSpPr>
+        <p:spPr>
+          <a:xfrm>
+            <a:off x="9017000" y="3452416"/>
+            <a:ext cx="2228850" cy="441920"/>
+          </a:xfrm>
+          <a:prstGeom prst="rect">
+            <a:avLst/>
+          </a:prstGeom>
+          <a:noFill/>
+        </p:spPr>
+        <p:txBody>
+          <a:bodyPr wrap="square" lIns="0" rIns="0" tIns="0" bIns="0" anchor="t">
+            <a:noAutofit/>
+          </a:bodyPr>
+          <a:lstStyle/>
+          <a:p>
+            <a:pPr algn="l">
+              <a:lnSpc>
+                <a:spcPts val="1739"/>
+              </a:lnSpc>
+            </a:pPr>
+            <a:r>
+              <a:rPr sz="1200" b="0" i="0">
+                <a:solidFill>
+                  <a:srgbClr val="3A4F63"/>
+                </a:solidFill>
+                <a:latin typeface="DM Sans"/>
+              </a:rPr>
+              <a:t>casussen bespreken</a:t>
+            </a:r>
+          </a:p>
+          <a:p>
+            <a:pPr algn="l">
+              <a:lnSpc>
+                <a:spcPts val="1739"/>
+              </a:lnSpc>
+            </a:pPr>
+            <a:r>
+              <a:rPr sz="1200" b="0" i="0">
+                <a:solidFill>
+                  <a:srgbClr val="3A4F63"/>
+                </a:solidFill>
+                <a:latin typeface="DM Sans"/>
+              </a:rPr>
+              <a:t>bijsturen</a:t>
+            </a:r>
+          </a:p>
+        </p:txBody>
+      </p:sp>
+      <p:sp>
+        <p:nvSpPr>
+          <p:cNvPr id="31" name="Rectangle 30"/>
+          <p:cNvSpPr/>
+          <p:nvPr/>
+        </p:nvSpPr>
+        <p:spPr>
+          <a:xfrm>
+            <a:off x="9017000" y="4463256"/>
+            <a:ext cx="2178050" cy="6350"/>
+          </a:xfrm>
+          <a:prstGeom prst="rect">
+            <a:avLst/>
+          </a:prstGeom>
+          <a:solidFill>
+            <a:srgbClr val="D3DFE8"/>
+          </a:solidFill>
+          <a:ln>
+            <a:noFill/>
+          </a:ln>
+          <a:effectLst/>
+        </p:spPr>
+        <p:style>
+          <a:lnRef idx="1">
+            <a:schemeClr val="accent1"/>
+          </a:lnRef>
+          <a:fillRef idx="3">
+            <a:schemeClr val="accent1"/>
+          </a:fillRef>
+          <a:effectRef idx="2">
+            <a:schemeClr val="accent1"/>
+          </a:effectRef>
+          <a:fontRef idx="minor">
+            <a:schemeClr val="lt1"/>
+          </a:fontRef>
+        </p:style>
+        <p:txBody>
+          <a:bodyPr rtlCol="0" anchor="ctr"/>
+          <a:lstStyle/>
+          <a:p>
+            <a:pPr algn="ctr"/>
+          </a:p>
+        </p:txBody>
+      </p:sp>
+      <p:sp>
+        <p:nvSpPr>
+          <p:cNvPr id="32" name="TextBox 31"/>
+          <p:cNvSpPr txBox="1"/>
+          <p:nvPr/>
+        </p:nvSpPr>
+        <p:spPr>
+          <a:xfrm>
+            <a:off x="9017000" y="4545806"/>
+            <a:ext cx="2228850" cy="181610"/>
+          </a:xfrm>
+          <a:prstGeom prst="rect">
+            <a:avLst/>
+          </a:prstGeom>
+          <a:noFill/>
+        </p:spPr>
+        <p:txBody>
+          <a:bodyPr wrap="none" lIns="0" rIns="0" tIns="0" bIns="0" anchor="t">
+            <a:noAutofit/>
+          </a:bodyPr>
+          <a:lstStyle/>
+          <a:p>
+            <a:pPr algn="l">
+              <a:lnSpc>
+                <a:spcPts val="1430"/>
+              </a:lnSpc>
+            </a:pPr>
+            <a:r>
+              <a:rPr sz="1100" b="0" i="0">
+                <a:solidFill>
+                  <a:srgbClr val="5A6E80"/>
+                </a:solidFill>
+                <a:latin typeface="DM Sans"/>
+              </a:rPr>
+              <a:t>online, individueel</a:t>
+            </a:r>
+          </a:p>
+        </p:txBody>
+      </p:sp>
+      <p:pic>
+        <p:nvPicPr>
+          <p:cNvPr id="33" name="Picture 32" descr="ec5c93e6f83f209b4e97ddfdecd480c8.png"/>
+          <p:cNvPicPr>
+            <a:picLocks noChangeAspect="1"/>
+          </p:cNvPicPr>
+          <p:nvPr/>
+        </p:nvPicPr>
+        <p:blipFill>
+          <a:blip r:embed="rId2"/>
+          <a:stretch>
+            <a:fillRect/>
+          </a:stretch>
+        </p:blipFill>
+        <p:spPr>
+          <a:xfrm>
+            <a:off x="812967" y="6261100"/>
+            <a:ext cx="171116" cy="203200"/>
+          </a:xfrm>
+          <a:prstGeom prst="rect">
+            <a:avLst/>
+          </a:prstGeom>
+        </p:spPr>
+      </p:pic>
+      <p:sp>
+        <p:nvSpPr>
+          <p:cNvPr id="34" name="TextBox 33"/>
+          <p:cNvSpPr txBox="1"/>
+          <p:nvPr/>
+        </p:nvSpPr>
+        <p:spPr>
+          <a:xfrm>
+            <a:off x="1066800" y="6254750"/>
+            <a:ext cx="4495800" cy="198120"/>
+          </a:xfrm>
+          <a:prstGeom prst="rect">
+            <a:avLst/>
+          </a:prstGeom>
+          <a:noFill/>
+        </p:spPr>
+        <p:txBody>
+          <a:bodyPr wrap="none" lIns="0" rIns="0" tIns="0" bIns="0" anchor="t">
+            <a:noAutofit/>
+          </a:bodyPr>
+          <a:lstStyle/>
+          <a:p>
+            <a:pPr algn="l"/>
+            <a:r>
+              <a:rPr sz="1200" b="0" i="0">
+                <a:solidFill>
+                  <a:srgbClr val="5A6E80"/>
+                </a:solidFill>
+                <a:latin typeface="JetBrains Mono"/>
+              </a:rPr>
+              <a:t>PARADISE · Voetklinieken, 12 oktober</a:t>
+            </a:r>
+          </a:p>
+        </p:txBody>
+      </p:sp>
+      <p:sp>
+        <p:nvSpPr>
+          <p:cNvPr id="35" name="TextBox 34"/>
+          <p:cNvSpPr txBox="1"/>
+          <p:nvPr/>
+        </p:nvSpPr>
+        <p:spPr>
+          <a:xfrm>
+            <a:off x="4978400" y="6254750"/>
+            <a:ext cx="6400800" cy="198120"/>
+          </a:xfrm>
+          <a:prstGeom prst="rect">
+            <a:avLst/>
+          </a:prstGeom>
+          <a:noFill/>
+        </p:spPr>
+        <p:txBody>
+          <a:bodyPr wrap="none" lIns="0" rIns="0" tIns="0" bIns="0" anchor="t">
+            <a:noAutofit/>
+          </a:bodyPr>
+          <a:lstStyle/>
+          <a:p>
+            <a:pPr algn="r"/>
+            <a:r>
+              <a:rPr sz="1200" b="0" i="0">
+                <a:solidFill>
+                  <a:srgbClr val="5A6E80"/>
+                </a:solidFill>
+                <a:latin typeface="JetBrains Mono"/>
+              </a:rPr>
+              <a:t>Bron · SEBIA-training, F. Dobbels, 23 sept 2026 · opleidingsplanning</a:t>
+            </a:r>
+          </a:p>
+        </p:txBody>
+      </p:sp>
+    </p:spTree>
+  </p:cSld>
+  <p:clrMapOvr>
+    <a:masterClrMapping/>
+  </p:clrMapOvr>
+  <p:transition xmlns:p14="http://schemas.microsoft.com/office/powerpoint/2010/main" spd="med" p14:dur="700">
+    <p:fade/>
+  </p:transition>
+</p:sld>
+</file>
+
+<file path=ppt/slides/slide17.xml><?xml version="1.0" encoding="utf-8"?>
 <p:sld xmlns:a="http://schemas.openxmlformats.org/drawingml/2006/main" xmlns:p="http://schemas.openxmlformats.org/presentationml/2006/main" xmlns:r="http://schemas.openxmlformats.org/officeDocument/2006/relationships">
   <p:cSld>
     <p:bg>
@@ -40248,7 +41759,7 @@
 </p:sld>
 </file>
 
-<file path=ppt/slides/slide17.xml><?xml version="1.0" encoding="utf-8"?>
+<file path=ppt/slides/slide18.xml><?xml version="1.0" encoding="utf-8"?>
 <p:sld xmlns:a="http://schemas.openxmlformats.org/drawingml/2006/main" xmlns:p="http://schemas.openxmlformats.org/presentationml/2006/main" xmlns:r="http://schemas.openxmlformats.org/officeDocument/2006/relationships">
   <p:cSld>
     <p:bg>
@@ -41145,7 +42656,7 @@
 </p:sld>
 </file>
 
-<file path=ppt/slides/slide18.xml><?xml version="1.0" encoding="utf-8"?>
+<file path=ppt/slides/slide19.xml><?xml version="1.0" encoding="utf-8"?>
 <p:sld xmlns:a="http://schemas.openxmlformats.org/drawingml/2006/main" xmlns:p="http://schemas.openxmlformats.org/presentationml/2006/main" xmlns:r="http://schemas.openxmlformats.org/officeDocument/2006/relationships">
   <p:cSld>
     <p:bg>
@@ -42585,7 +44096,951 @@
 </p:sld>
 </file>
 
-<file path=ppt/slides/slide19.xml><?xml version="1.0" encoding="utf-8"?>
+<file path=ppt/slides/slide2.xml><?xml version="1.0" encoding="utf-8"?>
+<p:sld xmlns:a="http://schemas.openxmlformats.org/drawingml/2006/main" xmlns:p="http://schemas.openxmlformats.org/presentationml/2006/main" xmlns:r="http://schemas.openxmlformats.org/officeDocument/2006/relationships">
+  <p:cSld>
+    <p:bg>
+      <p:bgPr>
+        <a:solidFill>
+          <a:srgbClr val="F2F6F9"/>
+        </a:solidFill>
+        <a:effectLst/>
+      </p:bgPr>
+    </p:bg>
+    <p:spTree>
+      <p:nvGrpSpPr>
+        <p:cNvPr id="1" name=""/>
+        <p:cNvGrpSpPr/>
+        <p:nvPr/>
+      </p:nvGrpSpPr>
+      <p:grpSpPr/>
+      <p:sp>
+        <p:nvSpPr>
+          <p:cNvPr id="2" name="TextBox 1"/>
+          <p:cNvSpPr txBox="1"/>
+          <p:nvPr/>
+        </p:nvSpPr>
+        <p:spPr>
+          <a:xfrm>
+            <a:off x="812800" y="812800"/>
+            <a:ext cx="10617200" cy="198120"/>
+          </a:xfrm>
+          <a:prstGeom prst="rect">
+            <a:avLst/>
+          </a:prstGeom>
+          <a:noFill/>
+        </p:spPr>
+        <p:txBody>
+          <a:bodyPr wrap="none" lIns="0" rIns="0" tIns="0" bIns="0" anchor="t">
+            <a:noAutofit/>
+          </a:bodyPr>
+          <a:lstStyle/>
+          <a:p>
+            <a:pPr algn="l"/>
+            <a:r>
+              <a:rPr sz="1200" b="0" i="0" spc="200">
+                <a:solidFill>
+                  <a:srgbClr val="0B6E8F"/>
+                </a:solidFill>
+                <a:latin typeface="JetBrains Mono"/>
+              </a:rPr>
+              <a:t>AGENDA</a:t>
+            </a:r>
+          </a:p>
+        </p:txBody>
+      </p:sp>
+      <p:sp>
+        <p:nvSpPr>
+          <p:cNvPr id="3" name="TextBox 2"/>
+          <p:cNvSpPr txBox="1"/>
+          <p:nvPr/>
+        </p:nvSpPr>
+        <p:spPr>
+          <a:xfrm>
+            <a:off x="812800" y="1111250"/>
+            <a:ext cx="10617200" cy="502920"/>
+          </a:xfrm>
+          <a:prstGeom prst="rect">
+            <a:avLst/>
+          </a:prstGeom>
+          <a:noFill/>
+        </p:spPr>
+        <p:txBody>
+          <a:bodyPr wrap="none" lIns="0" rIns="0" tIns="0" bIns="0" anchor="t">
+            <a:noAutofit/>
+          </a:bodyPr>
+          <a:lstStyle/>
+          <a:p>
+            <a:pPr algn="l">
+              <a:lnSpc>
+                <a:spcPts val="3960"/>
+              </a:lnSpc>
+            </a:pPr>
+            <a:r>
+              <a:rPr sz="3600" b="0" i="0" spc="-50">
+                <a:solidFill>
+                  <a:srgbClr val="0A2540"/>
+                </a:solidFill>
+                <a:latin typeface="DM Serif Display"/>
+              </a:rPr>
+              <a:t>Wat we vandaag overlopen</a:t>
+            </a:r>
+          </a:p>
+        </p:txBody>
+      </p:sp>
+      <p:sp>
+        <p:nvSpPr>
+          <p:cNvPr id="4" name="TextBox 3"/>
+          <p:cNvSpPr txBox="1"/>
+          <p:nvPr/>
+        </p:nvSpPr>
+        <p:spPr>
+          <a:xfrm>
+            <a:off x="812800" y="1963341"/>
+            <a:ext cx="431800" cy="234950"/>
+          </a:xfrm>
+          <a:prstGeom prst="rect">
+            <a:avLst/>
+          </a:prstGeom>
+          <a:noFill/>
+        </p:spPr>
+        <p:txBody>
+          <a:bodyPr wrap="none" lIns="0" rIns="0" tIns="0" bIns="0" anchor="t">
+            <a:noAutofit/>
+          </a:bodyPr>
+          <a:lstStyle/>
+          <a:p>
+            <a:pPr algn="l"/>
+            <a:r>
+              <a:rPr sz="1400" b="0" i="0">
+                <a:solidFill>
+                  <a:srgbClr val="0B6E8F"/>
+                </a:solidFill>
+                <a:latin typeface="JetBrains Mono"/>
+              </a:rPr>
+              <a:t>01</a:t>
+            </a:r>
+          </a:p>
+        </p:txBody>
+      </p:sp>
+      <p:sp>
+        <p:nvSpPr>
+          <p:cNvPr id="5" name="TextBox 4"/>
+          <p:cNvSpPr txBox="1"/>
+          <p:nvPr/>
+        </p:nvSpPr>
+        <p:spPr>
+          <a:xfrm>
+            <a:off x="1397000" y="1944291"/>
+            <a:ext cx="7721600" cy="269875"/>
+          </a:xfrm>
+          <a:prstGeom prst="rect">
+            <a:avLst/>
+          </a:prstGeom>
+          <a:noFill/>
+        </p:spPr>
+        <p:txBody>
+          <a:bodyPr wrap="none" lIns="0" rIns="0" tIns="0" bIns="0" anchor="t">
+            <a:noAutofit/>
+          </a:bodyPr>
+          <a:lstStyle/>
+          <a:p>
+            <a:pPr algn="l">
+              <a:lnSpc>
+                <a:spcPts val="2125"/>
+              </a:lnSpc>
+            </a:pPr>
+            <a:r>
+              <a:rPr sz="1700" b="0" i="0">
+                <a:solidFill>
+                  <a:srgbClr val="0A2540"/>
+                </a:solidFill>
+                <a:latin typeface="DM Sans"/>
+              </a:rPr>
+              <a:t>Stand van zaken</a:t>
+            </a:r>
+          </a:p>
+        </p:txBody>
+      </p:sp>
+      <p:sp>
+        <p:nvSpPr>
+          <p:cNvPr id="6" name="Rectangle 5"/>
+          <p:cNvSpPr/>
+          <p:nvPr/>
+        </p:nvSpPr>
+        <p:spPr>
+          <a:xfrm>
+            <a:off x="812800" y="2315766"/>
+            <a:ext cx="8255000" cy="6350"/>
+          </a:xfrm>
+          <a:prstGeom prst="rect">
+            <a:avLst/>
+          </a:prstGeom>
+          <a:solidFill>
+            <a:srgbClr val="D3DFE8"/>
+          </a:solidFill>
+          <a:ln>
+            <a:noFill/>
+          </a:ln>
+          <a:effectLst/>
+        </p:spPr>
+        <p:style>
+          <a:lnRef idx="1">
+            <a:schemeClr val="accent1"/>
+          </a:lnRef>
+          <a:fillRef idx="3">
+            <a:schemeClr val="accent1"/>
+          </a:fillRef>
+          <a:effectRef idx="2">
+            <a:schemeClr val="accent1"/>
+          </a:effectRef>
+          <a:fontRef idx="minor">
+            <a:schemeClr val="lt1"/>
+          </a:fontRef>
+        </p:style>
+        <p:txBody>
+          <a:bodyPr rtlCol="0" anchor="ctr"/>
+          <a:lstStyle/>
+          <a:p>
+            <a:pPr algn="ctr"/>
+          </a:p>
+        </p:txBody>
+      </p:sp>
+      <p:sp>
+        <p:nvSpPr>
+          <p:cNvPr id="7" name="TextBox 6"/>
+          <p:cNvSpPr txBox="1"/>
+          <p:nvPr/>
+        </p:nvSpPr>
+        <p:spPr>
+          <a:xfrm>
+            <a:off x="812800" y="2442766"/>
+            <a:ext cx="431800" cy="234950"/>
+          </a:xfrm>
+          <a:prstGeom prst="rect">
+            <a:avLst/>
+          </a:prstGeom>
+          <a:noFill/>
+        </p:spPr>
+        <p:txBody>
+          <a:bodyPr wrap="none" lIns="0" rIns="0" tIns="0" bIns="0" anchor="t">
+            <a:noAutofit/>
+          </a:bodyPr>
+          <a:lstStyle/>
+          <a:p>
+            <a:pPr algn="l"/>
+            <a:r>
+              <a:rPr sz="1400" b="0" i="0">
+                <a:solidFill>
+                  <a:srgbClr val="0B6E8F"/>
+                </a:solidFill>
+                <a:latin typeface="JetBrains Mono"/>
+              </a:rPr>
+              <a:t>02</a:t>
+            </a:r>
+          </a:p>
+        </p:txBody>
+      </p:sp>
+      <p:sp>
+        <p:nvSpPr>
+          <p:cNvPr id="8" name="TextBox 7"/>
+          <p:cNvSpPr txBox="1"/>
+          <p:nvPr/>
+        </p:nvSpPr>
+        <p:spPr>
+          <a:xfrm>
+            <a:off x="1397000" y="2423716"/>
+            <a:ext cx="7721600" cy="269875"/>
+          </a:xfrm>
+          <a:prstGeom prst="rect">
+            <a:avLst/>
+          </a:prstGeom>
+          <a:noFill/>
+        </p:spPr>
+        <p:txBody>
+          <a:bodyPr wrap="none" lIns="0" rIns="0" tIns="0" bIns="0" anchor="t">
+            <a:noAutofit/>
+          </a:bodyPr>
+          <a:lstStyle/>
+          <a:p>
+            <a:pPr algn="l">
+              <a:lnSpc>
+                <a:spcPts val="2125"/>
+              </a:lnSpc>
+            </a:pPr>
+            <a:r>
+              <a:rPr sz="1700" b="0" i="0">
+                <a:solidFill>
+                  <a:srgbClr val="0A2540"/>
+                </a:solidFill>
+                <a:latin typeface="DM Sans"/>
+              </a:rPr>
+              <a:t>Ontwikkelingen sinds 1 april</a:t>
+            </a:r>
+          </a:p>
+        </p:txBody>
+      </p:sp>
+      <p:sp>
+        <p:nvSpPr>
+          <p:cNvPr id="9" name="Rectangle 8"/>
+          <p:cNvSpPr/>
+          <p:nvPr/>
+        </p:nvSpPr>
+        <p:spPr>
+          <a:xfrm>
+            <a:off x="812800" y="2795191"/>
+            <a:ext cx="8255000" cy="6350"/>
+          </a:xfrm>
+          <a:prstGeom prst="rect">
+            <a:avLst/>
+          </a:prstGeom>
+          <a:solidFill>
+            <a:srgbClr val="D3DFE8"/>
+          </a:solidFill>
+          <a:ln>
+            <a:noFill/>
+          </a:ln>
+          <a:effectLst/>
+        </p:spPr>
+        <p:style>
+          <a:lnRef idx="1">
+            <a:schemeClr val="accent1"/>
+          </a:lnRef>
+          <a:fillRef idx="3">
+            <a:schemeClr val="accent1"/>
+          </a:fillRef>
+          <a:effectRef idx="2">
+            <a:schemeClr val="accent1"/>
+          </a:effectRef>
+          <a:fontRef idx="minor">
+            <a:schemeClr val="lt1"/>
+          </a:fontRef>
+        </p:style>
+        <p:txBody>
+          <a:bodyPr rtlCol="0" anchor="ctr"/>
+          <a:lstStyle/>
+          <a:p>
+            <a:pPr algn="ctr"/>
+          </a:p>
+        </p:txBody>
+      </p:sp>
+      <p:sp>
+        <p:nvSpPr>
+          <p:cNvPr id="10" name="TextBox 9"/>
+          <p:cNvSpPr txBox="1"/>
+          <p:nvPr/>
+        </p:nvSpPr>
+        <p:spPr>
+          <a:xfrm>
+            <a:off x="812800" y="2922191"/>
+            <a:ext cx="431800" cy="234950"/>
+          </a:xfrm>
+          <a:prstGeom prst="rect">
+            <a:avLst/>
+          </a:prstGeom>
+          <a:noFill/>
+        </p:spPr>
+        <p:txBody>
+          <a:bodyPr wrap="none" lIns="0" rIns="0" tIns="0" bIns="0" anchor="t">
+            <a:noAutofit/>
+          </a:bodyPr>
+          <a:lstStyle/>
+          <a:p>
+            <a:pPr algn="l"/>
+            <a:r>
+              <a:rPr sz="1400" b="0" i="0">
+                <a:solidFill>
+                  <a:srgbClr val="0B6E8F"/>
+                </a:solidFill>
+                <a:latin typeface="JetBrains Mono"/>
+              </a:rPr>
+              <a:t>03</a:t>
+            </a:r>
+          </a:p>
+        </p:txBody>
+      </p:sp>
+      <p:sp>
+        <p:nvSpPr>
+          <p:cNvPr id="11" name="TextBox 10"/>
+          <p:cNvSpPr txBox="1"/>
+          <p:nvPr/>
+        </p:nvSpPr>
+        <p:spPr>
+          <a:xfrm>
+            <a:off x="1397000" y="2903141"/>
+            <a:ext cx="7721600" cy="269875"/>
+          </a:xfrm>
+          <a:prstGeom prst="rect">
+            <a:avLst/>
+          </a:prstGeom>
+          <a:noFill/>
+        </p:spPr>
+        <p:txBody>
+          <a:bodyPr wrap="none" lIns="0" rIns="0" tIns="0" bIns="0" anchor="t">
+            <a:noAutofit/>
+          </a:bodyPr>
+          <a:lstStyle/>
+          <a:p>
+            <a:pPr algn="l">
+              <a:lnSpc>
+                <a:spcPts val="2125"/>
+              </a:lnSpc>
+            </a:pPr>
+            <a:r>
+              <a:rPr sz="1700" b="0" i="0">
+                <a:solidFill>
+                  <a:srgbClr val="0A2540"/>
+                </a:solidFill>
+                <a:latin typeface="DM Sans"/>
+              </a:rPr>
+              <a:t>Werkpakketten</a:t>
+            </a:r>
+          </a:p>
+        </p:txBody>
+      </p:sp>
+      <p:sp>
+        <p:nvSpPr>
+          <p:cNvPr id="12" name="Rectangle 11"/>
+          <p:cNvSpPr/>
+          <p:nvPr/>
+        </p:nvSpPr>
+        <p:spPr>
+          <a:xfrm>
+            <a:off x="812800" y="3274616"/>
+            <a:ext cx="8255000" cy="6350"/>
+          </a:xfrm>
+          <a:prstGeom prst="rect">
+            <a:avLst/>
+          </a:prstGeom>
+          <a:solidFill>
+            <a:srgbClr val="D3DFE8"/>
+          </a:solidFill>
+          <a:ln>
+            <a:noFill/>
+          </a:ln>
+          <a:effectLst/>
+        </p:spPr>
+        <p:style>
+          <a:lnRef idx="1">
+            <a:schemeClr val="accent1"/>
+          </a:lnRef>
+          <a:fillRef idx="3">
+            <a:schemeClr val="accent1"/>
+          </a:fillRef>
+          <a:effectRef idx="2">
+            <a:schemeClr val="accent1"/>
+          </a:effectRef>
+          <a:fontRef idx="minor">
+            <a:schemeClr val="lt1"/>
+          </a:fontRef>
+        </p:style>
+        <p:txBody>
+          <a:bodyPr rtlCol="0" anchor="ctr"/>
+          <a:lstStyle/>
+          <a:p>
+            <a:pPr algn="ctr"/>
+          </a:p>
+        </p:txBody>
+      </p:sp>
+      <p:sp>
+        <p:nvSpPr>
+          <p:cNvPr id="13" name="TextBox 12"/>
+          <p:cNvSpPr txBox="1"/>
+          <p:nvPr/>
+        </p:nvSpPr>
+        <p:spPr>
+          <a:xfrm>
+            <a:off x="812800" y="3401616"/>
+            <a:ext cx="431800" cy="234950"/>
+          </a:xfrm>
+          <a:prstGeom prst="rect">
+            <a:avLst/>
+          </a:prstGeom>
+          <a:noFill/>
+        </p:spPr>
+        <p:txBody>
+          <a:bodyPr wrap="none" lIns="0" rIns="0" tIns="0" bIns="0" anchor="t">
+            <a:noAutofit/>
+          </a:bodyPr>
+          <a:lstStyle/>
+          <a:p>
+            <a:pPr algn="l"/>
+            <a:r>
+              <a:rPr sz="1400" b="0" i="0">
+                <a:solidFill>
+                  <a:srgbClr val="0B6E8F"/>
+                </a:solidFill>
+                <a:latin typeface="JetBrains Mono"/>
+              </a:rPr>
+              <a:t>04</a:t>
+            </a:r>
+          </a:p>
+        </p:txBody>
+      </p:sp>
+      <p:sp>
+        <p:nvSpPr>
+          <p:cNvPr id="14" name="TextBox 13"/>
+          <p:cNvSpPr txBox="1"/>
+          <p:nvPr/>
+        </p:nvSpPr>
+        <p:spPr>
+          <a:xfrm>
+            <a:off x="1397000" y="3382566"/>
+            <a:ext cx="7721600" cy="269875"/>
+          </a:xfrm>
+          <a:prstGeom prst="rect">
+            <a:avLst/>
+          </a:prstGeom>
+          <a:noFill/>
+        </p:spPr>
+        <p:txBody>
+          <a:bodyPr wrap="none" lIns="0" rIns="0" tIns="0" bIns="0" anchor="t">
+            <a:noAutofit/>
+          </a:bodyPr>
+          <a:lstStyle/>
+          <a:p>
+            <a:pPr algn="l">
+              <a:lnSpc>
+                <a:spcPts val="2125"/>
+              </a:lnSpc>
+            </a:pPr>
+            <a:r>
+              <a:rPr sz="1700" b="0" i="0">
+                <a:solidFill>
+                  <a:srgbClr val="0A2540"/>
+                </a:solidFill>
+                <a:latin typeface="DM Sans"/>
+              </a:rPr>
+              <a:t>Aandachtspunten</a:t>
+            </a:r>
+          </a:p>
+        </p:txBody>
+      </p:sp>
+      <p:sp>
+        <p:nvSpPr>
+          <p:cNvPr id="15" name="Rectangle 14"/>
+          <p:cNvSpPr/>
+          <p:nvPr/>
+        </p:nvSpPr>
+        <p:spPr>
+          <a:xfrm>
+            <a:off x="812800" y="3754041"/>
+            <a:ext cx="8255000" cy="6350"/>
+          </a:xfrm>
+          <a:prstGeom prst="rect">
+            <a:avLst/>
+          </a:prstGeom>
+          <a:solidFill>
+            <a:srgbClr val="D3DFE8"/>
+          </a:solidFill>
+          <a:ln>
+            <a:noFill/>
+          </a:ln>
+          <a:effectLst/>
+        </p:spPr>
+        <p:style>
+          <a:lnRef idx="1">
+            <a:schemeClr val="accent1"/>
+          </a:lnRef>
+          <a:fillRef idx="3">
+            <a:schemeClr val="accent1"/>
+          </a:fillRef>
+          <a:effectRef idx="2">
+            <a:schemeClr val="accent1"/>
+          </a:effectRef>
+          <a:fontRef idx="minor">
+            <a:schemeClr val="lt1"/>
+          </a:fontRef>
+        </p:style>
+        <p:txBody>
+          <a:bodyPr rtlCol="0" anchor="ctr"/>
+          <a:lstStyle/>
+          <a:p>
+            <a:pPr algn="ctr"/>
+          </a:p>
+        </p:txBody>
+      </p:sp>
+      <p:sp>
+        <p:nvSpPr>
+          <p:cNvPr id="16" name="TextBox 15"/>
+          <p:cNvSpPr txBox="1"/>
+          <p:nvPr/>
+        </p:nvSpPr>
+        <p:spPr>
+          <a:xfrm>
+            <a:off x="812800" y="3881041"/>
+            <a:ext cx="431800" cy="234950"/>
+          </a:xfrm>
+          <a:prstGeom prst="rect">
+            <a:avLst/>
+          </a:prstGeom>
+          <a:noFill/>
+        </p:spPr>
+        <p:txBody>
+          <a:bodyPr wrap="none" lIns="0" rIns="0" tIns="0" bIns="0" anchor="t">
+            <a:noAutofit/>
+          </a:bodyPr>
+          <a:lstStyle/>
+          <a:p>
+            <a:pPr algn="l"/>
+            <a:r>
+              <a:rPr sz="1400" b="0" i="0">
+                <a:solidFill>
+                  <a:srgbClr val="0B6E8F"/>
+                </a:solidFill>
+                <a:latin typeface="JetBrains Mono"/>
+              </a:rPr>
+              <a:t>05</a:t>
+            </a:r>
+          </a:p>
+        </p:txBody>
+      </p:sp>
+      <p:sp>
+        <p:nvSpPr>
+          <p:cNvPr id="17" name="TextBox 16"/>
+          <p:cNvSpPr txBox="1"/>
+          <p:nvPr/>
+        </p:nvSpPr>
+        <p:spPr>
+          <a:xfrm>
+            <a:off x="1397000" y="3861991"/>
+            <a:ext cx="7721600" cy="269875"/>
+          </a:xfrm>
+          <a:prstGeom prst="rect">
+            <a:avLst/>
+          </a:prstGeom>
+          <a:noFill/>
+        </p:spPr>
+        <p:txBody>
+          <a:bodyPr wrap="none" lIns="0" rIns="0" tIns="0" bIns="0" anchor="t">
+            <a:noAutofit/>
+          </a:bodyPr>
+          <a:lstStyle/>
+          <a:p>
+            <a:pPr algn="l">
+              <a:lnSpc>
+                <a:spcPts val="2125"/>
+              </a:lnSpc>
+            </a:pPr>
+            <a:r>
+              <a:rPr sz="1700" b="0" i="0">
+                <a:solidFill>
+                  <a:srgbClr val="0A2540"/>
+                </a:solidFill>
+                <a:latin typeface="DM Sans"/>
+              </a:rPr>
+              <a:t>Mijlpalen en planning</a:t>
+            </a:r>
+          </a:p>
+        </p:txBody>
+      </p:sp>
+      <p:sp>
+        <p:nvSpPr>
+          <p:cNvPr id="18" name="Rectangle 17"/>
+          <p:cNvSpPr/>
+          <p:nvPr/>
+        </p:nvSpPr>
+        <p:spPr>
+          <a:xfrm>
+            <a:off x="812800" y="4233466"/>
+            <a:ext cx="8255000" cy="6350"/>
+          </a:xfrm>
+          <a:prstGeom prst="rect">
+            <a:avLst/>
+          </a:prstGeom>
+          <a:solidFill>
+            <a:srgbClr val="D3DFE8"/>
+          </a:solidFill>
+          <a:ln>
+            <a:noFill/>
+          </a:ln>
+          <a:effectLst/>
+        </p:spPr>
+        <p:style>
+          <a:lnRef idx="1">
+            <a:schemeClr val="accent1"/>
+          </a:lnRef>
+          <a:fillRef idx="3">
+            <a:schemeClr val="accent1"/>
+          </a:fillRef>
+          <a:effectRef idx="2">
+            <a:schemeClr val="accent1"/>
+          </a:effectRef>
+          <a:fontRef idx="minor">
+            <a:schemeClr val="lt1"/>
+          </a:fontRef>
+        </p:style>
+        <p:txBody>
+          <a:bodyPr rtlCol="0" anchor="ctr"/>
+          <a:lstStyle/>
+          <a:p>
+            <a:pPr algn="ctr"/>
+          </a:p>
+        </p:txBody>
+      </p:sp>
+      <p:sp>
+        <p:nvSpPr>
+          <p:cNvPr id="19" name="TextBox 18"/>
+          <p:cNvSpPr txBox="1"/>
+          <p:nvPr/>
+        </p:nvSpPr>
+        <p:spPr>
+          <a:xfrm>
+            <a:off x="812800" y="4360466"/>
+            <a:ext cx="431800" cy="234950"/>
+          </a:xfrm>
+          <a:prstGeom prst="rect">
+            <a:avLst/>
+          </a:prstGeom>
+          <a:noFill/>
+        </p:spPr>
+        <p:txBody>
+          <a:bodyPr wrap="none" lIns="0" rIns="0" tIns="0" bIns="0" anchor="t">
+            <a:noAutofit/>
+          </a:bodyPr>
+          <a:lstStyle/>
+          <a:p>
+            <a:pPr algn="l"/>
+            <a:r>
+              <a:rPr sz="1400" b="0" i="0">
+                <a:solidFill>
+                  <a:srgbClr val="0B6E8F"/>
+                </a:solidFill>
+                <a:latin typeface="JetBrains Mono"/>
+              </a:rPr>
+              <a:t>06</a:t>
+            </a:r>
+          </a:p>
+        </p:txBody>
+      </p:sp>
+      <p:sp>
+        <p:nvSpPr>
+          <p:cNvPr id="20" name="TextBox 19"/>
+          <p:cNvSpPr txBox="1"/>
+          <p:nvPr/>
+        </p:nvSpPr>
+        <p:spPr>
+          <a:xfrm>
+            <a:off x="1397000" y="4341416"/>
+            <a:ext cx="7721600" cy="269875"/>
+          </a:xfrm>
+          <a:prstGeom prst="rect">
+            <a:avLst/>
+          </a:prstGeom>
+          <a:noFill/>
+        </p:spPr>
+        <p:txBody>
+          <a:bodyPr wrap="none" lIns="0" rIns="0" tIns="0" bIns="0" anchor="t">
+            <a:noAutofit/>
+          </a:bodyPr>
+          <a:lstStyle/>
+          <a:p>
+            <a:pPr algn="l">
+              <a:lnSpc>
+                <a:spcPts val="2125"/>
+              </a:lnSpc>
+            </a:pPr>
+            <a:r>
+              <a:rPr sz="1700" b="0" i="0">
+                <a:solidFill>
+                  <a:srgbClr val="0A2540"/>
+                </a:solidFill>
+                <a:latin typeface="DM Sans"/>
+              </a:rPr>
+              <a:t>Bespreking</a:t>
+            </a:r>
+          </a:p>
+        </p:txBody>
+      </p:sp>
+      <p:sp>
+        <p:nvSpPr>
+          <p:cNvPr id="21" name="Rectangle 20"/>
+          <p:cNvSpPr/>
+          <p:nvPr/>
+        </p:nvSpPr>
+        <p:spPr>
+          <a:xfrm>
+            <a:off x="812800" y="4712891"/>
+            <a:ext cx="8255000" cy="6350"/>
+          </a:xfrm>
+          <a:prstGeom prst="rect">
+            <a:avLst/>
+          </a:prstGeom>
+          <a:solidFill>
+            <a:srgbClr val="D3DFE8"/>
+          </a:solidFill>
+          <a:ln>
+            <a:noFill/>
+          </a:ln>
+          <a:effectLst/>
+        </p:spPr>
+        <p:style>
+          <a:lnRef idx="1">
+            <a:schemeClr val="accent1"/>
+          </a:lnRef>
+          <a:fillRef idx="3">
+            <a:schemeClr val="accent1"/>
+          </a:fillRef>
+          <a:effectRef idx="2">
+            <a:schemeClr val="accent1"/>
+          </a:effectRef>
+          <a:fontRef idx="minor">
+            <a:schemeClr val="lt1"/>
+          </a:fontRef>
+        </p:style>
+        <p:txBody>
+          <a:bodyPr rtlCol="0" anchor="ctr"/>
+          <a:lstStyle/>
+          <a:p>
+            <a:pPr algn="ctr"/>
+          </a:p>
+        </p:txBody>
+      </p:sp>
+      <p:sp>
+        <p:nvSpPr>
+          <p:cNvPr id="22" name="TextBox 21"/>
+          <p:cNvSpPr txBox="1"/>
+          <p:nvPr/>
+        </p:nvSpPr>
+        <p:spPr>
+          <a:xfrm>
+            <a:off x="812800" y="4839891"/>
+            <a:ext cx="431800" cy="234950"/>
+          </a:xfrm>
+          <a:prstGeom prst="rect">
+            <a:avLst/>
+          </a:prstGeom>
+          <a:noFill/>
+        </p:spPr>
+        <p:txBody>
+          <a:bodyPr wrap="none" lIns="0" rIns="0" tIns="0" bIns="0" anchor="t">
+            <a:noAutofit/>
+          </a:bodyPr>
+          <a:lstStyle/>
+          <a:p>
+            <a:pPr algn="l"/>
+            <a:r>
+              <a:rPr sz="1400" b="0" i="0">
+                <a:solidFill>
+                  <a:srgbClr val="0B6E8F"/>
+                </a:solidFill>
+                <a:latin typeface="JetBrains Mono"/>
+              </a:rPr>
+              <a:t>07</a:t>
+            </a:r>
+          </a:p>
+        </p:txBody>
+      </p:sp>
+      <p:sp>
+        <p:nvSpPr>
+          <p:cNvPr id="23" name="TextBox 22"/>
+          <p:cNvSpPr txBox="1"/>
+          <p:nvPr/>
+        </p:nvSpPr>
+        <p:spPr>
+          <a:xfrm>
+            <a:off x="1397000" y="4820841"/>
+            <a:ext cx="7721600" cy="269875"/>
+          </a:xfrm>
+          <a:prstGeom prst="rect">
+            <a:avLst/>
+          </a:prstGeom>
+          <a:noFill/>
+        </p:spPr>
+        <p:txBody>
+          <a:bodyPr wrap="none" lIns="0" rIns="0" tIns="0" bIns="0" anchor="t">
+            <a:noAutofit/>
+          </a:bodyPr>
+          <a:lstStyle/>
+          <a:p>
+            <a:pPr algn="l">
+              <a:lnSpc>
+                <a:spcPts val="2125"/>
+              </a:lnSpc>
+            </a:pPr>
+            <a:r>
+              <a:rPr sz="1700" b="0" i="0">
+                <a:solidFill>
+                  <a:srgbClr val="0A2540"/>
+                </a:solidFill>
+                <a:latin typeface="DM Sans"/>
+              </a:rPr>
+              <a:t>Tour de table</a:t>
+            </a:r>
+          </a:p>
+        </p:txBody>
+      </p:sp>
+      <p:pic>
+        <p:nvPicPr>
+          <p:cNvPr id="24" name="Picture 23" descr="ec5c93e6f83f209b4e97ddfdecd480c8.png"/>
+          <p:cNvPicPr>
+            <a:picLocks noChangeAspect="1"/>
+          </p:cNvPicPr>
+          <p:nvPr/>
+        </p:nvPicPr>
+        <p:blipFill>
+          <a:blip r:embed="rId2"/>
+          <a:stretch>
+            <a:fillRect/>
+          </a:stretch>
+        </p:blipFill>
+        <p:spPr>
+          <a:xfrm>
+            <a:off x="812967" y="6261100"/>
+            <a:ext cx="171116" cy="203200"/>
+          </a:xfrm>
+          <a:prstGeom prst="rect">
+            <a:avLst/>
+          </a:prstGeom>
+        </p:spPr>
+      </p:pic>
+      <p:sp>
+        <p:nvSpPr>
+          <p:cNvPr id="25" name="TextBox 24"/>
+          <p:cNvSpPr txBox="1"/>
+          <p:nvPr/>
+        </p:nvSpPr>
+        <p:spPr>
+          <a:xfrm>
+            <a:off x="1066800" y="6254750"/>
+            <a:ext cx="4495800" cy="198120"/>
+          </a:xfrm>
+          <a:prstGeom prst="rect">
+            <a:avLst/>
+          </a:prstGeom>
+          <a:noFill/>
+        </p:spPr>
+        <p:txBody>
+          <a:bodyPr wrap="none" lIns="0" rIns="0" tIns="0" bIns="0" anchor="t">
+            <a:noAutofit/>
+          </a:bodyPr>
+          <a:lstStyle/>
+          <a:p>
+            <a:pPr algn="l"/>
+            <a:r>
+              <a:rPr sz="1200" b="0" i="0">
+                <a:solidFill>
+                  <a:srgbClr val="5A6E80"/>
+                </a:solidFill>
+                <a:latin typeface="JetBrains Mono"/>
+              </a:rPr>
+              <a:t>PARADISE · Voetklinieken, 12 oktober</a:t>
+            </a:r>
+          </a:p>
+        </p:txBody>
+      </p:sp>
+    </p:spTree>
+  </p:cSld>
+  <p:clrMapOvr>
+    <a:masterClrMapping/>
+  </p:clrMapOvr>
+  <p:transition xmlns:p14="http://schemas.microsoft.com/office/powerpoint/2010/main" spd="med" p14:dur="700">
+    <p:fade/>
+  </p:transition>
+</p:sld>
+</file>
+
+<file path=ppt/slides/slide20.xml><?xml version="1.0" encoding="utf-8"?>
 <p:sld xmlns:a="http://schemas.openxmlformats.org/drawingml/2006/main" xmlns:p="http://schemas.openxmlformats.org/presentationml/2006/main" xmlns:r="http://schemas.openxmlformats.org/officeDocument/2006/relationships">
   <p:cSld>
     <p:bg>
@@ -43275,951 +45730,7 @@
 </p:sld>
 </file>
 
-<file path=ppt/slides/slide2.xml><?xml version="1.0" encoding="utf-8"?>
-<p:sld xmlns:a="http://schemas.openxmlformats.org/drawingml/2006/main" xmlns:p="http://schemas.openxmlformats.org/presentationml/2006/main" xmlns:r="http://schemas.openxmlformats.org/officeDocument/2006/relationships">
-  <p:cSld>
-    <p:bg>
-      <p:bgPr>
-        <a:solidFill>
-          <a:srgbClr val="F2F6F9"/>
-        </a:solidFill>
-        <a:effectLst/>
-      </p:bgPr>
-    </p:bg>
-    <p:spTree>
-      <p:nvGrpSpPr>
-        <p:cNvPr id="1" name=""/>
-        <p:cNvGrpSpPr/>
-        <p:nvPr/>
-      </p:nvGrpSpPr>
-      <p:grpSpPr/>
-      <p:sp>
-        <p:nvSpPr>
-          <p:cNvPr id="2" name="TextBox 1"/>
-          <p:cNvSpPr txBox="1"/>
-          <p:nvPr/>
-        </p:nvSpPr>
-        <p:spPr>
-          <a:xfrm>
-            <a:off x="812800" y="812800"/>
-            <a:ext cx="10617200" cy="198120"/>
-          </a:xfrm>
-          <a:prstGeom prst="rect">
-            <a:avLst/>
-          </a:prstGeom>
-          <a:noFill/>
-        </p:spPr>
-        <p:txBody>
-          <a:bodyPr wrap="none" lIns="0" rIns="0" tIns="0" bIns="0" anchor="t">
-            <a:noAutofit/>
-          </a:bodyPr>
-          <a:lstStyle/>
-          <a:p>
-            <a:pPr algn="l"/>
-            <a:r>
-              <a:rPr sz="1200" b="0" i="0" spc="200">
-                <a:solidFill>
-                  <a:srgbClr val="0B6E8F"/>
-                </a:solidFill>
-                <a:latin typeface="JetBrains Mono"/>
-              </a:rPr>
-              <a:t>AGENDA</a:t>
-            </a:r>
-          </a:p>
-        </p:txBody>
-      </p:sp>
-      <p:sp>
-        <p:nvSpPr>
-          <p:cNvPr id="3" name="TextBox 2"/>
-          <p:cNvSpPr txBox="1"/>
-          <p:nvPr/>
-        </p:nvSpPr>
-        <p:spPr>
-          <a:xfrm>
-            <a:off x="812800" y="1111250"/>
-            <a:ext cx="10617200" cy="502920"/>
-          </a:xfrm>
-          <a:prstGeom prst="rect">
-            <a:avLst/>
-          </a:prstGeom>
-          <a:noFill/>
-        </p:spPr>
-        <p:txBody>
-          <a:bodyPr wrap="none" lIns="0" rIns="0" tIns="0" bIns="0" anchor="t">
-            <a:noAutofit/>
-          </a:bodyPr>
-          <a:lstStyle/>
-          <a:p>
-            <a:pPr algn="l">
-              <a:lnSpc>
-                <a:spcPts val="3960"/>
-              </a:lnSpc>
-            </a:pPr>
-            <a:r>
-              <a:rPr sz="3600" b="0" i="0" spc="-50">
-                <a:solidFill>
-                  <a:srgbClr val="0A2540"/>
-                </a:solidFill>
-                <a:latin typeface="DM Serif Display"/>
-              </a:rPr>
-              <a:t>Wat we vandaag overlopen</a:t>
-            </a:r>
-          </a:p>
-        </p:txBody>
-      </p:sp>
-      <p:sp>
-        <p:nvSpPr>
-          <p:cNvPr id="4" name="TextBox 3"/>
-          <p:cNvSpPr txBox="1"/>
-          <p:nvPr/>
-        </p:nvSpPr>
-        <p:spPr>
-          <a:xfrm>
-            <a:off x="812800" y="1963341"/>
-            <a:ext cx="431800" cy="234950"/>
-          </a:xfrm>
-          <a:prstGeom prst="rect">
-            <a:avLst/>
-          </a:prstGeom>
-          <a:noFill/>
-        </p:spPr>
-        <p:txBody>
-          <a:bodyPr wrap="none" lIns="0" rIns="0" tIns="0" bIns="0" anchor="t">
-            <a:noAutofit/>
-          </a:bodyPr>
-          <a:lstStyle/>
-          <a:p>
-            <a:pPr algn="l"/>
-            <a:r>
-              <a:rPr sz="1400" b="0" i="0">
-                <a:solidFill>
-                  <a:srgbClr val="0B6E8F"/>
-                </a:solidFill>
-                <a:latin typeface="JetBrains Mono"/>
-              </a:rPr>
-              <a:t>01</a:t>
-            </a:r>
-          </a:p>
-        </p:txBody>
-      </p:sp>
-      <p:sp>
-        <p:nvSpPr>
-          <p:cNvPr id="5" name="TextBox 4"/>
-          <p:cNvSpPr txBox="1"/>
-          <p:nvPr/>
-        </p:nvSpPr>
-        <p:spPr>
-          <a:xfrm>
-            <a:off x="1397000" y="1944291"/>
-            <a:ext cx="7721600" cy="269875"/>
-          </a:xfrm>
-          <a:prstGeom prst="rect">
-            <a:avLst/>
-          </a:prstGeom>
-          <a:noFill/>
-        </p:spPr>
-        <p:txBody>
-          <a:bodyPr wrap="none" lIns="0" rIns="0" tIns="0" bIns="0" anchor="t">
-            <a:noAutofit/>
-          </a:bodyPr>
-          <a:lstStyle/>
-          <a:p>
-            <a:pPr algn="l">
-              <a:lnSpc>
-                <a:spcPts val="2125"/>
-              </a:lnSpc>
-            </a:pPr>
-            <a:r>
-              <a:rPr sz="1700" b="0" i="0">
-                <a:solidFill>
-                  <a:srgbClr val="0A2540"/>
-                </a:solidFill>
-                <a:latin typeface="DM Sans"/>
-              </a:rPr>
-              <a:t>Stand van zaken</a:t>
-            </a:r>
-          </a:p>
-        </p:txBody>
-      </p:sp>
-      <p:sp>
-        <p:nvSpPr>
-          <p:cNvPr id="6" name="Rectangle 5"/>
-          <p:cNvSpPr/>
-          <p:nvPr/>
-        </p:nvSpPr>
-        <p:spPr>
-          <a:xfrm>
-            <a:off x="812800" y="2315766"/>
-            <a:ext cx="8255000" cy="6350"/>
-          </a:xfrm>
-          <a:prstGeom prst="rect">
-            <a:avLst/>
-          </a:prstGeom>
-          <a:solidFill>
-            <a:srgbClr val="D3DFE8"/>
-          </a:solidFill>
-          <a:ln>
-            <a:noFill/>
-          </a:ln>
-          <a:effectLst/>
-        </p:spPr>
-        <p:style>
-          <a:lnRef idx="1">
-            <a:schemeClr val="accent1"/>
-          </a:lnRef>
-          <a:fillRef idx="3">
-            <a:schemeClr val="accent1"/>
-          </a:fillRef>
-          <a:effectRef idx="2">
-            <a:schemeClr val="accent1"/>
-          </a:effectRef>
-          <a:fontRef idx="minor">
-            <a:schemeClr val="lt1"/>
-          </a:fontRef>
-        </p:style>
-        <p:txBody>
-          <a:bodyPr rtlCol="0" anchor="ctr"/>
-          <a:lstStyle/>
-          <a:p>
-            <a:pPr algn="ctr"/>
-          </a:p>
-        </p:txBody>
-      </p:sp>
-      <p:sp>
-        <p:nvSpPr>
-          <p:cNvPr id="7" name="TextBox 6"/>
-          <p:cNvSpPr txBox="1"/>
-          <p:nvPr/>
-        </p:nvSpPr>
-        <p:spPr>
-          <a:xfrm>
-            <a:off x="812800" y="2442766"/>
-            <a:ext cx="431800" cy="234950"/>
-          </a:xfrm>
-          <a:prstGeom prst="rect">
-            <a:avLst/>
-          </a:prstGeom>
-          <a:noFill/>
-        </p:spPr>
-        <p:txBody>
-          <a:bodyPr wrap="none" lIns="0" rIns="0" tIns="0" bIns="0" anchor="t">
-            <a:noAutofit/>
-          </a:bodyPr>
-          <a:lstStyle/>
-          <a:p>
-            <a:pPr algn="l"/>
-            <a:r>
-              <a:rPr sz="1400" b="0" i="0">
-                <a:solidFill>
-                  <a:srgbClr val="0B6E8F"/>
-                </a:solidFill>
-                <a:latin typeface="JetBrains Mono"/>
-              </a:rPr>
-              <a:t>02</a:t>
-            </a:r>
-          </a:p>
-        </p:txBody>
-      </p:sp>
-      <p:sp>
-        <p:nvSpPr>
-          <p:cNvPr id="8" name="TextBox 7"/>
-          <p:cNvSpPr txBox="1"/>
-          <p:nvPr/>
-        </p:nvSpPr>
-        <p:spPr>
-          <a:xfrm>
-            <a:off x="1397000" y="2423716"/>
-            <a:ext cx="7721600" cy="269875"/>
-          </a:xfrm>
-          <a:prstGeom prst="rect">
-            <a:avLst/>
-          </a:prstGeom>
-          <a:noFill/>
-        </p:spPr>
-        <p:txBody>
-          <a:bodyPr wrap="none" lIns="0" rIns="0" tIns="0" bIns="0" anchor="t">
-            <a:noAutofit/>
-          </a:bodyPr>
-          <a:lstStyle/>
-          <a:p>
-            <a:pPr algn="l">
-              <a:lnSpc>
-                <a:spcPts val="2125"/>
-              </a:lnSpc>
-            </a:pPr>
-            <a:r>
-              <a:rPr sz="1700" b="0" i="0">
-                <a:solidFill>
-                  <a:srgbClr val="0A2540"/>
-                </a:solidFill>
-                <a:latin typeface="DM Sans"/>
-              </a:rPr>
-              <a:t>Ontwikkelingen sinds 1 april</a:t>
-            </a:r>
-          </a:p>
-        </p:txBody>
-      </p:sp>
-      <p:sp>
-        <p:nvSpPr>
-          <p:cNvPr id="9" name="Rectangle 8"/>
-          <p:cNvSpPr/>
-          <p:nvPr/>
-        </p:nvSpPr>
-        <p:spPr>
-          <a:xfrm>
-            <a:off x="812800" y="2795191"/>
-            <a:ext cx="8255000" cy="6350"/>
-          </a:xfrm>
-          <a:prstGeom prst="rect">
-            <a:avLst/>
-          </a:prstGeom>
-          <a:solidFill>
-            <a:srgbClr val="D3DFE8"/>
-          </a:solidFill>
-          <a:ln>
-            <a:noFill/>
-          </a:ln>
-          <a:effectLst/>
-        </p:spPr>
-        <p:style>
-          <a:lnRef idx="1">
-            <a:schemeClr val="accent1"/>
-          </a:lnRef>
-          <a:fillRef idx="3">
-            <a:schemeClr val="accent1"/>
-          </a:fillRef>
-          <a:effectRef idx="2">
-            <a:schemeClr val="accent1"/>
-          </a:effectRef>
-          <a:fontRef idx="minor">
-            <a:schemeClr val="lt1"/>
-          </a:fontRef>
-        </p:style>
-        <p:txBody>
-          <a:bodyPr rtlCol="0" anchor="ctr"/>
-          <a:lstStyle/>
-          <a:p>
-            <a:pPr algn="ctr"/>
-          </a:p>
-        </p:txBody>
-      </p:sp>
-      <p:sp>
-        <p:nvSpPr>
-          <p:cNvPr id="10" name="TextBox 9"/>
-          <p:cNvSpPr txBox="1"/>
-          <p:nvPr/>
-        </p:nvSpPr>
-        <p:spPr>
-          <a:xfrm>
-            <a:off x="812800" y="2922191"/>
-            <a:ext cx="431800" cy="234950"/>
-          </a:xfrm>
-          <a:prstGeom prst="rect">
-            <a:avLst/>
-          </a:prstGeom>
-          <a:noFill/>
-        </p:spPr>
-        <p:txBody>
-          <a:bodyPr wrap="none" lIns="0" rIns="0" tIns="0" bIns="0" anchor="t">
-            <a:noAutofit/>
-          </a:bodyPr>
-          <a:lstStyle/>
-          <a:p>
-            <a:pPr algn="l"/>
-            <a:r>
-              <a:rPr sz="1400" b="0" i="0">
-                <a:solidFill>
-                  <a:srgbClr val="0B6E8F"/>
-                </a:solidFill>
-                <a:latin typeface="JetBrains Mono"/>
-              </a:rPr>
-              <a:t>03</a:t>
-            </a:r>
-          </a:p>
-        </p:txBody>
-      </p:sp>
-      <p:sp>
-        <p:nvSpPr>
-          <p:cNvPr id="11" name="TextBox 10"/>
-          <p:cNvSpPr txBox="1"/>
-          <p:nvPr/>
-        </p:nvSpPr>
-        <p:spPr>
-          <a:xfrm>
-            <a:off x="1397000" y="2903141"/>
-            <a:ext cx="7721600" cy="269875"/>
-          </a:xfrm>
-          <a:prstGeom prst="rect">
-            <a:avLst/>
-          </a:prstGeom>
-          <a:noFill/>
-        </p:spPr>
-        <p:txBody>
-          <a:bodyPr wrap="none" lIns="0" rIns="0" tIns="0" bIns="0" anchor="t">
-            <a:noAutofit/>
-          </a:bodyPr>
-          <a:lstStyle/>
-          <a:p>
-            <a:pPr algn="l">
-              <a:lnSpc>
-                <a:spcPts val="2125"/>
-              </a:lnSpc>
-            </a:pPr>
-            <a:r>
-              <a:rPr sz="1700" b="0" i="0">
-                <a:solidFill>
-                  <a:srgbClr val="0A2540"/>
-                </a:solidFill>
-                <a:latin typeface="DM Sans"/>
-              </a:rPr>
-              <a:t>Werkpakketten</a:t>
-            </a:r>
-          </a:p>
-        </p:txBody>
-      </p:sp>
-      <p:sp>
-        <p:nvSpPr>
-          <p:cNvPr id="12" name="Rectangle 11"/>
-          <p:cNvSpPr/>
-          <p:nvPr/>
-        </p:nvSpPr>
-        <p:spPr>
-          <a:xfrm>
-            <a:off x="812800" y="3274616"/>
-            <a:ext cx="8255000" cy="6350"/>
-          </a:xfrm>
-          <a:prstGeom prst="rect">
-            <a:avLst/>
-          </a:prstGeom>
-          <a:solidFill>
-            <a:srgbClr val="D3DFE8"/>
-          </a:solidFill>
-          <a:ln>
-            <a:noFill/>
-          </a:ln>
-          <a:effectLst/>
-        </p:spPr>
-        <p:style>
-          <a:lnRef idx="1">
-            <a:schemeClr val="accent1"/>
-          </a:lnRef>
-          <a:fillRef idx="3">
-            <a:schemeClr val="accent1"/>
-          </a:fillRef>
-          <a:effectRef idx="2">
-            <a:schemeClr val="accent1"/>
-          </a:effectRef>
-          <a:fontRef idx="minor">
-            <a:schemeClr val="lt1"/>
-          </a:fontRef>
-        </p:style>
-        <p:txBody>
-          <a:bodyPr rtlCol="0" anchor="ctr"/>
-          <a:lstStyle/>
-          <a:p>
-            <a:pPr algn="ctr"/>
-          </a:p>
-        </p:txBody>
-      </p:sp>
-      <p:sp>
-        <p:nvSpPr>
-          <p:cNvPr id="13" name="TextBox 12"/>
-          <p:cNvSpPr txBox="1"/>
-          <p:nvPr/>
-        </p:nvSpPr>
-        <p:spPr>
-          <a:xfrm>
-            <a:off x="812800" y="3401616"/>
-            <a:ext cx="431800" cy="234950"/>
-          </a:xfrm>
-          <a:prstGeom prst="rect">
-            <a:avLst/>
-          </a:prstGeom>
-          <a:noFill/>
-        </p:spPr>
-        <p:txBody>
-          <a:bodyPr wrap="none" lIns="0" rIns="0" tIns="0" bIns="0" anchor="t">
-            <a:noAutofit/>
-          </a:bodyPr>
-          <a:lstStyle/>
-          <a:p>
-            <a:pPr algn="l"/>
-            <a:r>
-              <a:rPr sz="1400" b="0" i="0">
-                <a:solidFill>
-                  <a:srgbClr val="0B6E8F"/>
-                </a:solidFill>
-                <a:latin typeface="JetBrains Mono"/>
-              </a:rPr>
-              <a:t>04</a:t>
-            </a:r>
-          </a:p>
-        </p:txBody>
-      </p:sp>
-      <p:sp>
-        <p:nvSpPr>
-          <p:cNvPr id="14" name="TextBox 13"/>
-          <p:cNvSpPr txBox="1"/>
-          <p:nvPr/>
-        </p:nvSpPr>
-        <p:spPr>
-          <a:xfrm>
-            <a:off x="1397000" y="3382566"/>
-            <a:ext cx="7721600" cy="269875"/>
-          </a:xfrm>
-          <a:prstGeom prst="rect">
-            <a:avLst/>
-          </a:prstGeom>
-          <a:noFill/>
-        </p:spPr>
-        <p:txBody>
-          <a:bodyPr wrap="none" lIns="0" rIns="0" tIns="0" bIns="0" anchor="t">
-            <a:noAutofit/>
-          </a:bodyPr>
-          <a:lstStyle/>
-          <a:p>
-            <a:pPr algn="l">
-              <a:lnSpc>
-                <a:spcPts val="2125"/>
-              </a:lnSpc>
-            </a:pPr>
-            <a:r>
-              <a:rPr sz="1700" b="0" i="0">
-                <a:solidFill>
-                  <a:srgbClr val="0A2540"/>
-                </a:solidFill>
-                <a:latin typeface="DM Sans"/>
-              </a:rPr>
-              <a:t>Aandachtspunten</a:t>
-            </a:r>
-          </a:p>
-        </p:txBody>
-      </p:sp>
-      <p:sp>
-        <p:nvSpPr>
-          <p:cNvPr id="15" name="Rectangle 14"/>
-          <p:cNvSpPr/>
-          <p:nvPr/>
-        </p:nvSpPr>
-        <p:spPr>
-          <a:xfrm>
-            <a:off x="812800" y="3754041"/>
-            <a:ext cx="8255000" cy="6350"/>
-          </a:xfrm>
-          <a:prstGeom prst="rect">
-            <a:avLst/>
-          </a:prstGeom>
-          <a:solidFill>
-            <a:srgbClr val="D3DFE8"/>
-          </a:solidFill>
-          <a:ln>
-            <a:noFill/>
-          </a:ln>
-          <a:effectLst/>
-        </p:spPr>
-        <p:style>
-          <a:lnRef idx="1">
-            <a:schemeClr val="accent1"/>
-          </a:lnRef>
-          <a:fillRef idx="3">
-            <a:schemeClr val="accent1"/>
-          </a:fillRef>
-          <a:effectRef idx="2">
-            <a:schemeClr val="accent1"/>
-          </a:effectRef>
-          <a:fontRef idx="minor">
-            <a:schemeClr val="lt1"/>
-          </a:fontRef>
-        </p:style>
-        <p:txBody>
-          <a:bodyPr rtlCol="0" anchor="ctr"/>
-          <a:lstStyle/>
-          <a:p>
-            <a:pPr algn="ctr"/>
-          </a:p>
-        </p:txBody>
-      </p:sp>
-      <p:sp>
-        <p:nvSpPr>
-          <p:cNvPr id="16" name="TextBox 15"/>
-          <p:cNvSpPr txBox="1"/>
-          <p:nvPr/>
-        </p:nvSpPr>
-        <p:spPr>
-          <a:xfrm>
-            <a:off x="812800" y="3881041"/>
-            <a:ext cx="431800" cy="234950"/>
-          </a:xfrm>
-          <a:prstGeom prst="rect">
-            <a:avLst/>
-          </a:prstGeom>
-          <a:noFill/>
-        </p:spPr>
-        <p:txBody>
-          <a:bodyPr wrap="none" lIns="0" rIns="0" tIns="0" bIns="0" anchor="t">
-            <a:noAutofit/>
-          </a:bodyPr>
-          <a:lstStyle/>
-          <a:p>
-            <a:pPr algn="l"/>
-            <a:r>
-              <a:rPr sz="1400" b="0" i="0">
-                <a:solidFill>
-                  <a:srgbClr val="0B6E8F"/>
-                </a:solidFill>
-                <a:latin typeface="JetBrains Mono"/>
-              </a:rPr>
-              <a:t>05</a:t>
-            </a:r>
-          </a:p>
-        </p:txBody>
-      </p:sp>
-      <p:sp>
-        <p:nvSpPr>
-          <p:cNvPr id="17" name="TextBox 16"/>
-          <p:cNvSpPr txBox="1"/>
-          <p:nvPr/>
-        </p:nvSpPr>
-        <p:spPr>
-          <a:xfrm>
-            <a:off x="1397000" y="3861991"/>
-            <a:ext cx="7721600" cy="269875"/>
-          </a:xfrm>
-          <a:prstGeom prst="rect">
-            <a:avLst/>
-          </a:prstGeom>
-          <a:noFill/>
-        </p:spPr>
-        <p:txBody>
-          <a:bodyPr wrap="none" lIns="0" rIns="0" tIns="0" bIns="0" anchor="t">
-            <a:noAutofit/>
-          </a:bodyPr>
-          <a:lstStyle/>
-          <a:p>
-            <a:pPr algn="l">
-              <a:lnSpc>
-                <a:spcPts val="2125"/>
-              </a:lnSpc>
-            </a:pPr>
-            <a:r>
-              <a:rPr sz="1700" b="0" i="0">
-                <a:solidFill>
-                  <a:srgbClr val="0A2540"/>
-                </a:solidFill>
-                <a:latin typeface="DM Sans"/>
-              </a:rPr>
-              <a:t>Mijlpalen en planning</a:t>
-            </a:r>
-          </a:p>
-        </p:txBody>
-      </p:sp>
-      <p:sp>
-        <p:nvSpPr>
-          <p:cNvPr id="18" name="Rectangle 17"/>
-          <p:cNvSpPr/>
-          <p:nvPr/>
-        </p:nvSpPr>
-        <p:spPr>
-          <a:xfrm>
-            <a:off x="812800" y="4233466"/>
-            <a:ext cx="8255000" cy="6350"/>
-          </a:xfrm>
-          <a:prstGeom prst="rect">
-            <a:avLst/>
-          </a:prstGeom>
-          <a:solidFill>
-            <a:srgbClr val="D3DFE8"/>
-          </a:solidFill>
-          <a:ln>
-            <a:noFill/>
-          </a:ln>
-          <a:effectLst/>
-        </p:spPr>
-        <p:style>
-          <a:lnRef idx="1">
-            <a:schemeClr val="accent1"/>
-          </a:lnRef>
-          <a:fillRef idx="3">
-            <a:schemeClr val="accent1"/>
-          </a:fillRef>
-          <a:effectRef idx="2">
-            <a:schemeClr val="accent1"/>
-          </a:effectRef>
-          <a:fontRef idx="minor">
-            <a:schemeClr val="lt1"/>
-          </a:fontRef>
-        </p:style>
-        <p:txBody>
-          <a:bodyPr rtlCol="0" anchor="ctr"/>
-          <a:lstStyle/>
-          <a:p>
-            <a:pPr algn="ctr"/>
-          </a:p>
-        </p:txBody>
-      </p:sp>
-      <p:sp>
-        <p:nvSpPr>
-          <p:cNvPr id="19" name="TextBox 18"/>
-          <p:cNvSpPr txBox="1"/>
-          <p:nvPr/>
-        </p:nvSpPr>
-        <p:spPr>
-          <a:xfrm>
-            <a:off x="812800" y="4360466"/>
-            <a:ext cx="431800" cy="234950"/>
-          </a:xfrm>
-          <a:prstGeom prst="rect">
-            <a:avLst/>
-          </a:prstGeom>
-          <a:noFill/>
-        </p:spPr>
-        <p:txBody>
-          <a:bodyPr wrap="none" lIns="0" rIns="0" tIns="0" bIns="0" anchor="t">
-            <a:noAutofit/>
-          </a:bodyPr>
-          <a:lstStyle/>
-          <a:p>
-            <a:pPr algn="l"/>
-            <a:r>
-              <a:rPr sz="1400" b="0" i="0">
-                <a:solidFill>
-                  <a:srgbClr val="0B6E8F"/>
-                </a:solidFill>
-                <a:latin typeface="JetBrains Mono"/>
-              </a:rPr>
-              <a:t>06</a:t>
-            </a:r>
-          </a:p>
-        </p:txBody>
-      </p:sp>
-      <p:sp>
-        <p:nvSpPr>
-          <p:cNvPr id="20" name="TextBox 19"/>
-          <p:cNvSpPr txBox="1"/>
-          <p:nvPr/>
-        </p:nvSpPr>
-        <p:spPr>
-          <a:xfrm>
-            <a:off x="1397000" y="4341416"/>
-            <a:ext cx="7721600" cy="269875"/>
-          </a:xfrm>
-          <a:prstGeom prst="rect">
-            <a:avLst/>
-          </a:prstGeom>
-          <a:noFill/>
-        </p:spPr>
-        <p:txBody>
-          <a:bodyPr wrap="none" lIns="0" rIns="0" tIns="0" bIns="0" anchor="t">
-            <a:noAutofit/>
-          </a:bodyPr>
-          <a:lstStyle/>
-          <a:p>
-            <a:pPr algn="l">
-              <a:lnSpc>
-                <a:spcPts val="2125"/>
-              </a:lnSpc>
-            </a:pPr>
-            <a:r>
-              <a:rPr sz="1700" b="0" i="0">
-                <a:solidFill>
-                  <a:srgbClr val="0A2540"/>
-                </a:solidFill>
-                <a:latin typeface="DM Sans"/>
-              </a:rPr>
-              <a:t>Bespreking</a:t>
-            </a:r>
-          </a:p>
-        </p:txBody>
-      </p:sp>
-      <p:sp>
-        <p:nvSpPr>
-          <p:cNvPr id="21" name="Rectangle 20"/>
-          <p:cNvSpPr/>
-          <p:nvPr/>
-        </p:nvSpPr>
-        <p:spPr>
-          <a:xfrm>
-            <a:off x="812800" y="4712891"/>
-            <a:ext cx="8255000" cy="6350"/>
-          </a:xfrm>
-          <a:prstGeom prst="rect">
-            <a:avLst/>
-          </a:prstGeom>
-          <a:solidFill>
-            <a:srgbClr val="D3DFE8"/>
-          </a:solidFill>
-          <a:ln>
-            <a:noFill/>
-          </a:ln>
-          <a:effectLst/>
-        </p:spPr>
-        <p:style>
-          <a:lnRef idx="1">
-            <a:schemeClr val="accent1"/>
-          </a:lnRef>
-          <a:fillRef idx="3">
-            <a:schemeClr val="accent1"/>
-          </a:fillRef>
-          <a:effectRef idx="2">
-            <a:schemeClr val="accent1"/>
-          </a:effectRef>
-          <a:fontRef idx="minor">
-            <a:schemeClr val="lt1"/>
-          </a:fontRef>
-        </p:style>
-        <p:txBody>
-          <a:bodyPr rtlCol="0" anchor="ctr"/>
-          <a:lstStyle/>
-          <a:p>
-            <a:pPr algn="ctr"/>
-          </a:p>
-        </p:txBody>
-      </p:sp>
-      <p:sp>
-        <p:nvSpPr>
-          <p:cNvPr id="22" name="TextBox 21"/>
-          <p:cNvSpPr txBox="1"/>
-          <p:nvPr/>
-        </p:nvSpPr>
-        <p:spPr>
-          <a:xfrm>
-            <a:off x="812800" y="4839891"/>
-            <a:ext cx="431800" cy="234950"/>
-          </a:xfrm>
-          <a:prstGeom prst="rect">
-            <a:avLst/>
-          </a:prstGeom>
-          <a:noFill/>
-        </p:spPr>
-        <p:txBody>
-          <a:bodyPr wrap="none" lIns="0" rIns="0" tIns="0" bIns="0" anchor="t">
-            <a:noAutofit/>
-          </a:bodyPr>
-          <a:lstStyle/>
-          <a:p>
-            <a:pPr algn="l"/>
-            <a:r>
-              <a:rPr sz="1400" b="0" i="0">
-                <a:solidFill>
-                  <a:srgbClr val="0B6E8F"/>
-                </a:solidFill>
-                <a:latin typeface="JetBrains Mono"/>
-              </a:rPr>
-              <a:t>07</a:t>
-            </a:r>
-          </a:p>
-        </p:txBody>
-      </p:sp>
-      <p:sp>
-        <p:nvSpPr>
-          <p:cNvPr id="23" name="TextBox 22"/>
-          <p:cNvSpPr txBox="1"/>
-          <p:nvPr/>
-        </p:nvSpPr>
-        <p:spPr>
-          <a:xfrm>
-            <a:off x="1397000" y="4820841"/>
-            <a:ext cx="7721600" cy="269875"/>
-          </a:xfrm>
-          <a:prstGeom prst="rect">
-            <a:avLst/>
-          </a:prstGeom>
-          <a:noFill/>
-        </p:spPr>
-        <p:txBody>
-          <a:bodyPr wrap="none" lIns="0" rIns="0" tIns="0" bIns="0" anchor="t">
-            <a:noAutofit/>
-          </a:bodyPr>
-          <a:lstStyle/>
-          <a:p>
-            <a:pPr algn="l">
-              <a:lnSpc>
-                <a:spcPts val="2125"/>
-              </a:lnSpc>
-            </a:pPr>
-            <a:r>
-              <a:rPr sz="1700" b="0" i="0">
-                <a:solidFill>
-                  <a:srgbClr val="0A2540"/>
-                </a:solidFill>
-                <a:latin typeface="DM Sans"/>
-              </a:rPr>
-              <a:t>Tour de table</a:t>
-            </a:r>
-          </a:p>
-        </p:txBody>
-      </p:sp>
-      <p:pic>
-        <p:nvPicPr>
-          <p:cNvPr id="24" name="Picture 23" descr="ec5c93e6f83f209b4e97ddfdecd480c8.png"/>
-          <p:cNvPicPr>
-            <a:picLocks noChangeAspect="1"/>
-          </p:cNvPicPr>
-          <p:nvPr/>
-        </p:nvPicPr>
-        <p:blipFill>
-          <a:blip r:embed="rId2"/>
-          <a:stretch>
-            <a:fillRect/>
-          </a:stretch>
-        </p:blipFill>
-        <p:spPr>
-          <a:xfrm>
-            <a:off x="812967" y="6261100"/>
-            <a:ext cx="171116" cy="203200"/>
-          </a:xfrm>
-          <a:prstGeom prst="rect">
-            <a:avLst/>
-          </a:prstGeom>
-        </p:spPr>
-      </p:pic>
-      <p:sp>
-        <p:nvSpPr>
-          <p:cNvPr id="25" name="TextBox 24"/>
-          <p:cNvSpPr txBox="1"/>
-          <p:nvPr/>
-        </p:nvSpPr>
-        <p:spPr>
-          <a:xfrm>
-            <a:off x="1066800" y="6254750"/>
-            <a:ext cx="4495800" cy="198120"/>
-          </a:xfrm>
-          <a:prstGeom prst="rect">
-            <a:avLst/>
-          </a:prstGeom>
-          <a:noFill/>
-        </p:spPr>
-        <p:txBody>
-          <a:bodyPr wrap="none" lIns="0" rIns="0" tIns="0" bIns="0" anchor="t">
-            <a:noAutofit/>
-          </a:bodyPr>
-          <a:lstStyle/>
-          <a:p>
-            <a:pPr algn="l"/>
-            <a:r>
-              <a:rPr sz="1200" b="0" i="0">
-                <a:solidFill>
-                  <a:srgbClr val="5A6E80"/>
-                </a:solidFill>
-                <a:latin typeface="JetBrains Mono"/>
-              </a:rPr>
-              <a:t>PARADISE · Voetklinieken, 12 oktober</a:t>
-            </a:r>
-          </a:p>
-        </p:txBody>
-      </p:sp>
-    </p:spTree>
-  </p:cSld>
-  <p:clrMapOvr>
-    <a:masterClrMapping/>
-  </p:clrMapOvr>
-  <p:transition xmlns:p14="http://schemas.microsoft.com/office/powerpoint/2010/main" spd="med" p14:dur="700">
-    <p:fade/>
-  </p:transition>
-</p:sld>
-</file>
-
-<file path=ppt/slides/slide20.xml><?xml version="1.0" encoding="utf-8"?>
+<file path=ppt/slides/slide21.xml><?xml version="1.0" encoding="utf-8"?>
 <p:sld xmlns:a="http://schemas.openxmlformats.org/drawingml/2006/main" xmlns:p="http://schemas.openxmlformats.org/presentationml/2006/main" xmlns:r="http://schemas.openxmlformats.org/officeDocument/2006/relationships">
   <p:cSld>
     <p:bg>
@@ -45773,7 +47284,7 @@
 </p:sld>
 </file>
 
-<file path=ppt/slides/slide21.xml><?xml version="1.0" encoding="utf-8"?>
+<file path=ppt/slides/slide22.xml><?xml version="1.0" encoding="utf-8"?>
 <p:sld xmlns:a="http://schemas.openxmlformats.org/drawingml/2006/main" xmlns:p="http://schemas.openxmlformats.org/presentationml/2006/main" xmlns:r="http://schemas.openxmlformats.org/officeDocument/2006/relationships">
   <p:cSld>
     <p:bg>
@@ -46301,7 +47812,7 @@
 </p:sld>
 </file>
 
-<file path=ppt/slides/slide22.xml><?xml version="1.0" encoding="utf-8"?>
+<file path=ppt/slides/slide23.xml><?xml version="1.0" encoding="utf-8"?>
 <p:sld xmlns:a="http://schemas.openxmlformats.org/drawingml/2006/main" xmlns:p="http://schemas.openxmlformats.org/presentationml/2006/main" xmlns:r="http://schemas.openxmlformats.org/officeDocument/2006/relationships">
   <p:cSld>
     <p:bg>
@@ -47434,7 +48945,7 @@
 </p:sld>
 </file>
 
-<file path=ppt/slides/slide23.xml><?xml version="1.0" encoding="utf-8"?>
+<file path=ppt/slides/slide24.xml><?xml version="1.0" encoding="utf-8"?>
 <p:sld xmlns:a="http://schemas.openxmlformats.org/drawingml/2006/main" xmlns:p="http://schemas.openxmlformats.org/presentationml/2006/main" xmlns:r="http://schemas.openxmlformats.org/officeDocument/2006/relationships">
   <p:cSld>
     <p:bg>
@@ -49352,7 +50863,7 @@
       </p:sp>
       <p:pic>
         <p:nvPicPr>
-          <p:cNvPr id="13" name="Picture 12" descr="784fe050203227ed71fc366b12ff83a7.png"/>
+          <p:cNvPr id="13" name="Picture 12" descr="bca0e7442a2bdffe745679463c941007.png"/>
           <p:cNvPicPr>
             <a:picLocks noChangeAspect="1"/>
           </p:cNvPicPr>
@@ -49366,8 +50877,8 @@
         </p:blipFill>
         <p:spPr>
           <a:xfrm>
-            <a:off x="5207000" y="953262"/>
-            <a:ext cx="6172200" cy="4608576"/>
+            <a:off x="5207000" y="1521619"/>
+            <a:ext cx="6172200" cy="3471862"/>
           </a:xfrm>
           <a:prstGeom prst="rect">
             <a:avLst/>

</xml_diff>